<commit_message>
docs: upgrade pitch deck - AKKA emblem, family hero image, 'by Mithun R', footers, links & thank-you close
</commit_message>
<xml_diff>
--- a/docs/deck/Akkaverse-Pitch-Deck.pptx
+++ b/docs/deck/Akkaverse-Pitch-Deck.pptx
@@ -3112,7 +3112,7 @@
             <a:avLst/>
           </a:prstGeom>
           <a:solidFill>
-            <a:srgbClr val="0E0B16"/>
+            <a:srgbClr val="0C0A14"/>
           </a:solidFill>
           <a:ln>
             <a:noFill/>
@@ -3150,7 +3150,7 @@
         <p:spPr>
           <a:xfrm>
             <a:off x="0" y="0"/>
-            <a:ext cx="256032" cy="6858000"/>
+            <a:ext cx="237744" cy="6858000"/>
           </a:xfrm>
           <a:prstGeom prst="rect">
             <a:avLst/>
@@ -3193,8 +3193,8 @@
         </p:nvSpPr>
         <p:spPr>
           <a:xfrm>
-            <a:off x="256032" y="0"/>
-            <a:ext cx="91440" cy="6858000"/>
+            <a:off x="237744" y="0"/>
+            <a:ext cx="82296" cy="6858000"/>
           </a:xfrm>
           <a:prstGeom prst="rect">
             <a:avLst/>
@@ -3231,20 +3231,22 @@
       </p:sp>
       <p:sp>
         <p:nvSpPr>
-          <p:cNvPr id="5" name="Rectangle 4"/>
+          <p:cNvPr id="5" name="Oval 4"/>
           <p:cNvSpPr/>
           <p:nvPr/>
         </p:nvSpPr>
         <p:spPr>
           <a:xfrm>
-            <a:off x="7680960" y="-1097280"/>
-            <a:ext cx="5486400" cy="5486400"/>
-          </a:xfrm>
-          <a:prstGeom prst="rect">
+            <a:off x="7" y="-2"/>
+            <a:ext cx="5943600" cy="5943600"/>
+          </a:xfrm>
+          <a:prstGeom prst="ellipse">
             <a:avLst/>
           </a:prstGeom>
           <a:solidFill>
-            <a:srgbClr val="1A142C"/>
+            <a:srgbClr val="E03E8A">
+              <a:alpha val="12000"/>
+            </a:srgbClr>
           </a:solidFill>
           <a:ln>
             <a:noFill/>
@@ -3281,14 +3283,16 @@
         </p:nvSpPr>
         <p:spPr>
           <a:xfrm>
-            <a:off x="10149840" y="1005840"/>
-            <a:ext cx="1463040" cy="1463040"/>
+            <a:off x="9" y="3"/>
+            <a:ext cx="5029200" cy="5029200"/>
           </a:xfrm>
           <a:prstGeom prst="ellipse">
             <a:avLst/>
           </a:prstGeom>
           <a:solidFill>
-            <a:srgbClr val="FF9F1C"/>
+            <a:srgbClr val="FF9F1C">
+              <a:alpha val="10000"/>
+            </a:srgbClr>
           </a:solidFill>
           <a:ln>
             <a:noFill/>
@@ -3319,23 +3323,27 @@
       </p:sp>
       <p:sp>
         <p:nvSpPr>
-          <p:cNvPr id="7" name="Oval 6"/>
+          <p:cNvPr id="7" name="Rounded Rectangle 6"/>
           <p:cNvSpPr/>
           <p:nvPr/>
         </p:nvSpPr>
         <p:spPr>
           <a:xfrm>
-            <a:off x="9326880" y="4480560"/>
-            <a:ext cx="1005840" cy="1005840"/>
-          </a:xfrm>
-          <a:prstGeom prst="ellipse">
-            <a:avLst/>
+            <a:off x="8275320" y="640080"/>
+            <a:ext cx="3337560" cy="5577840"/>
+          </a:xfrm>
+          <a:prstGeom prst="roundRect">
+            <a:avLst>
+              <a:gd name="adj" fmla="val 5000"/>
+            </a:avLst>
           </a:prstGeom>
           <a:solidFill>
-            <a:srgbClr val="E03E8A"/>
+            <a:srgbClr val="1A142C"/>
           </a:solidFill>
-          <a:ln>
-            <a:noFill/>
+          <a:ln w="19050">
+            <a:solidFill>
+              <a:srgbClr val="FF9F1C"/>
+            </a:solidFill>
           </a:ln>
           <a:effectLst/>
         </p:spPr>
@@ -3361,25 +3369,96 @@
           </a:p>
         </p:txBody>
       </p:sp>
-      <p:sp>
-        <p:nvSpPr>
-          <p:cNvPr id="8" name="Oval 7"/>
+      <p:pic>
+        <p:nvPicPr>
+          <p:cNvPr id="8" name="Picture 7" descr="family-hero.png"/>
+          <p:cNvPicPr>
+            <a:picLocks noChangeAspect="1"/>
+          </p:cNvPicPr>
+          <p:nvPr/>
+        </p:nvPicPr>
+        <p:blipFill>
+          <a:blip r:embed="rId2"/>
+          <a:stretch>
+            <a:fillRect/>
+          </a:stretch>
+        </p:blipFill>
+        <p:spPr>
+          <a:xfrm>
+            <a:off x="8394192" y="758952"/>
+            <a:ext cx="3005401" cy="5340096"/>
+          </a:xfrm>
+          <a:prstGeom prst="rect">
+            <a:avLst/>
+          </a:prstGeom>
+        </p:spPr>
+      </p:pic>
+      <p:sp>
+        <p:nvSpPr>
+          <p:cNvPr id="9" name="TextBox 8"/>
+          <p:cNvSpPr txBox="1"/>
+          <p:nvPr/>
+        </p:nvSpPr>
+        <p:spPr>
+          <a:xfrm>
+            <a:off x="8275320" y="5870448"/>
+            <a:ext cx="3337560" cy="365760"/>
+          </a:xfrm>
+          <a:prstGeom prst="rect">
+            <a:avLst/>
+          </a:prstGeom>
+          <a:noFill/>
+        </p:spPr>
+        <p:txBody>
+          <a:bodyPr wrap="square" anchor="t" lIns="0" rIns="0" tIns="0" bIns="0">
+            <a:spAutoFit/>
+          </a:bodyPr>
+          <a:lstStyle/>
+          <a:p>
+            <a:pPr algn="ctr">
+              <a:lnSpc>
+                <a:spcPct val="100000"/>
+              </a:lnSpc>
+              <a:spcBef>
+                <a:spcPts val="0"/>
+              </a:spcBef>
+              <a:spcAft>
+                <a:spcPts val="600"/>
+              </a:spcAft>
+            </a:pPr>
+            <a:r>
+              <a:rPr sz="1100" b="0" i="1">
+                <a:solidFill>
+                  <a:srgbClr val="B9B0C8"/>
+                </a:solidFill>
+                <a:latin typeface="Segoe UI"/>
+              </a:rPr>
+              <a:t>Three generations, one voice — preserved.</a:t>
+            </a:r>
+          </a:p>
+        </p:txBody>
+      </p:sp>
+      <p:sp>
+        <p:nvSpPr>
+          <p:cNvPr id="10" name="Oval 9"/>
           <p:cNvSpPr/>
           <p:nvPr/>
         </p:nvSpPr>
         <p:spPr>
           <a:xfrm>
-            <a:off x="11064240" y="3291840"/>
-            <a:ext cx="640080" cy="640080"/>
+            <a:off x="754380" y="708660"/>
+            <a:ext cx="1051560" cy="1051560"/>
           </a:xfrm>
           <a:prstGeom prst="ellipse">
             <a:avLst/>
           </a:prstGeom>
           <a:solidFill>
-            <a:srgbClr val="2EC4B6"/>
+            <a:srgbClr val="F7F2E7"/>
           </a:solidFill>
-          <a:ln>
-            <a:noFill/>
+          <a:ln w="31750">
+            <a:solidFill>
+              <a:srgbClr val="1B4FB0"/>
+            </a:solidFill>
           </a:ln>
           <a:effectLst/>
         </p:spPr>
@@ -3407,14 +3486,58 @@
       </p:sp>
       <p:sp>
         <p:nvSpPr>
-          <p:cNvPr id="9" name="TextBox 8"/>
+          <p:cNvPr id="11" name="Oval 10"/>
+          <p:cNvSpPr/>
+          <p:nvPr/>
+        </p:nvSpPr>
+        <p:spPr>
+          <a:xfrm>
+            <a:off x="859536" y="813816"/>
+            <a:ext cx="841247" cy="841247"/>
+          </a:xfrm>
+          <a:prstGeom prst="ellipse">
+            <a:avLst/>
+          </a:prstGeom>
+          <a:noFill/>
+          <a:ln w="19050">
+            <a:solidFill>
+              <a:srgbClr val="1B4FB0"/>
+            </a:solidFill>
+          </a:ln>
+          <a:effectLst/>
+        </p:spPr>
+        <p:style>
+          <a:lnRef idx="1">
+            <a:schemeClr val="accent1"/>
+          </a:lnRef>
+          <a:fillRef idx="3">
+            <a:schemeClr val="accent1"/>
+          </a:fillRef>
+          <a:effectRef idx="2">
+            <a:schemeClr val="accent1"/>
+          </a:effectRef>
+          <a:fontRef idx="minor">
+            <a:schemeClr val="lt1"/>
+          </a:fontRef>
+        </p:style>
+        <p:txBody>
+          <a:bodyPr rtlCol="0" anchor="ctr"/>
+          <a:lstStyle/>
+          <a:p>
+            <a:pPr algn="ctr"/>
+          </a:p>
+        </p:txBody>
+      </p:sp>
+      <p:sp>
+        <p:nvSpPr>
+          <p:cNvPr id="12" name="TextBox 11"/>
           <p:cNvSpPr txBox="1"/>
           <p:nvPr/>
         </p:nvSpPr>
         <p:spPr>
           <a:xfrm>
-            <a:off x="868680" y="1371600"/>
-            <a:ext cx="8229600" cy="914400"/>
+            <a:off x="754380" y="1066190"/>
+            <a:ext cx="1051560" cy="336499"/>
           </a:xfrm>
           <a:prstGeom prst="rect">
             <a:avLst/>
@@ -3422,7 +3545,97 @@
           <a:noFill/>
         </p:spPr>
         <p:txBody>
-          <a:bodyPr wrap="square" anchor="t" lIns="0" rIns="0" tIns="0" bIns="0">
+          <a:bodyPr wrap="square" anchor="ctr" lIns="0" rIns="0" tIns="0" bIns="0">
+            <a:spAutoFit/>
+          </a:bodyPr>
+          <a:lstStyle/>
+          <a:p>
+            <a:pPr algn="ctr">
+              <a:lnSpc>
+                <a:spcPct val="100000"/>
+              </a:lnSpc>
+              <a:spcBef>
+                <a:spcPts val="0"/>
+              </a:spcBef>
+              <a:spcAft>
+                <a:spcPts val="0"/>
+              </a:spcAft>
+            </a:pPr>
+            <a:r>
+              <a:rPr sz="1500" b="1" i="0">
+                <a:solidFill>
+                  <a:srgbClr val="C8272B"/>
+                </a:solidFill>
+                <a:latin typeface="Georgia"/>
+              </a:rPr>
+              <a:t>ಅಕ್ಕ</a:t>
+            </a:r>
+          </a:p>
+        </p:txBody>
+      </p:sp>
+      <p:sp>
+        <p:nvSpPr>
+          <p:cNvPr id="13" name="TextBox 12"/>
+          <p:cNvSpPr txBox="1"/>
+          <p:nvPr/>
+        </p:nvSpPr>
+        <p:spPr>
+          <a:xfrm>
+            <a:off x="754380" y="1339596"/>
+            <a:ext cx="1051560" cy="273405"/>
+          </a:xfrm>
+          <a:prstGeom prst="rect">
+            <a:avLst/>
+          </a:prstGeom>
+          <a:noFill/>
+        </p:spPr>
+        <p:txBody>
+          <a:bodyPr wrap="square" anchor="ctr" lIns="0" rIns="0" tIns="0" bIns="0">
+            <a:spAutoFit/>
+          </a:bodyPr>
+          <a:lstStyle/>
+          <a:p>
+            <a:pPr algn="ctr">
+              <a:lnSpc>
+                <a:spcPct val="100000"/>
+              </a:lnSpc>
+              <a:spcBef>
+                <a:spcPts val="0"/>
+              </a:spcBef>
+              <a:spcAft>
+                <a:spcPts val="0"/>
+              </a:spcAft>
+            </a:pPr>
+            <a:r>
+              <a:rPr sz="1100" b="1" i="0">
+                <a:solidFill>
+                  <a:srgbClr val="1B4FB0"/>
+                </a:solidFill>
+                <a:latin typeface="Segoe UI"/>
+              </a:rPr>
+              <a:t>AKKA</a:t>
+            </a:r>
+          </a:p>
+        </p:txBody>
+      </p:sp>
+      <p:sp>
+        <p:nvSpPr>
+          <p:cNvPr id="14" name="TextBox 13"/>
+          <p:cNvSpPr txBox="1"/>
+          <p:nvPr/>
+        </p:nvSpPr>
+        <p:spPr>
+          <a:xfrm>
+            <a:off x="1965960" y="896112"/>
+            <a:ext cx="5486400" cy="731520"/>
+          </a:xfrm>
+          <a:prstGeom prst="rect">
+            <a:avLst/>
+          </a:prstGeom>
+          <a:noFill/>
+        </p:spPr>
+        <p:txBody>
+          <a:bodyPr wrap="square" anchor="ctr" lIns="0" rIns="0" tIns="0" bIns="0">
             <a:spAutoFit/>
           </a:bodyPr>
           <a:lstStyle/>
@@ -3439,7 +3652,7 @@
               </a:spcAft>
             </a:pPr>
             <a:r>
-              <a:rPr sz="2000" b="1" i="0">
+              <a:rPr sz="1900" b="1" i="0">
                 <a:solidFill>
                   <a:srgbClr val="2EC4B6"/>
                 </a:solidFill>
@@ -3452,14 +3665,14 @@
       </p:sp>
       <p:sp>
         <p:nvSpPr>
-          <p:cNvPr id="10" name="TextBox 9"/>
+          <p:cNvPr id="15" name="TextBox 14"/>
           <p:cNvSpPr txBox="1"/>
           <p:nvPr/>
         </p:nvSpPr>
         <p:spPr>
           <a:xfrm>
-            <a:off x="822960" y="2011680"/>
-            <a:ext cx="9601200" cy="2377440"/>
+            <a:off x="777240" y="2148840"/>
+            <a:ext cx="7498079" cy="2286000"/>
           </a:xfrm>
           <a:prstGeom prst="rect">
             <a:avLst/>
@@ -3484,28 +3697,28 @@
               </a:spcAft>
             </a:pPr>
             <a:r>
-              <a:rPr sz="6600" b="1" i="0">
+              <a:rPr sz="6000" b="1" i="0">
                 <a:solidFill>
                   <a:srgbClr val="F7F2E7"/>
                 </a:solidFill>
                 <a:latin typeface="Georgia"/>
               </a:rPr>
-              <a:t>Preserve. Teach.
-Celebrate.</a:t>
-            </a:r>
-          </a:p>
-        </p:txBody>
-      </p:sp>
-      <p:sp>
-        <p:nvSpPr>
-          <p:cNvPr id="11" name="TextBox 10"/>
+              <a:t>Preserve.
+Teach. Celebrate.</a:t>
+            </a:r>
+          </a:p>
+        </p:txBody>
+      </p:sp>
+      <p:sp>
+        <p:nvSpPr>
+          <p:cNvPr id="16" name="TextBox 15"/>
           <p:cNvSpPr txBox="1"/>
           <p:nvPr/>
         </p:nvSpPr>
         <p:spPr>
           <a:xfrm>
-            <a:off x="868680" y="4343400"/>
-            <a:ext cx="9601200" cy="914400"/>
+            <a:off x="822960" y="4526280"/>
+            <a:ext cx="7223760" cy="1005840"/>
           </a:xfrm>
           <a:prstGeom prst="rect">
             <a:avLst/>
@@ -3530,27 +3743,27 @@
               </a:spcAft>
             </a:pPr>
             <a:r>
-              <a:rPr sz="1900" b="0" i="0">
+              <a:rPr sz="1800" b="0" i="0">
                 <a:solidFill>
                   <a:srgbClr val="B9B0C8"/>
                 </a:solidFill>
                 <a:latin typeface="Segoe UI"/>
               </a:rPr>
-              <a:t>A bilingual (English + ಕನ್ನಡ) local-first platform that keeps Kannada language, family memory, and heritage alive — one voice at a time.</a:t>
-            </a:r>
-          </a:p>
-        </p:txBody>
-      </p:sp>
-      <p:sp>
-        <p:nvSpPr>
-          <p:cNvPr id="12" name="TextBox 11"/>
+              <a:t>A bilingual (English + ಕನ್ನಡ) local-first platform that keeps Kannada language, family memory and heritage alive — one voice at a time.</a:t>
+            </a:r>
+          </a:p>
+        </p:txBody>
+      </p:sp>
+      <p:sp>
+        <p:nvSpPr>
+          <p:cNvPr id="17" name="TextBox 16"/>
           <p:cNvSpPr txBox="1"/>
           <p:nvPr/>
         </p:nvSpPr>
         <p:spPr>
           <a:xfrm>
-            <a:off x="868680" y="5806440"/>
-            <a:ext cx="10424160" cy="640080"/>
+            <a:off x="822960" y="5715000"/>
+            <a:ext cx="7223760" cy="457200"/>
           </a:xfrm>
           <a:prstGeom prst="rect">
             <a:avLst/>
@@ -3575,13 +3788,58 @@
               </a:spcAft>
             </a:pPr>
             <a:r>
-              <a:rPr sz="1400" b="1" i="0">
+              <a:rPr sz="1700" b="1" i="0">
                 <a:solidFill>
                   <a:srgbClr val="FF9F1C"/>
+                </a:solidFill>
+                <a:latin typeface="Georgia"/>
+              </a:rPr>
+              <a:t>by Mithun R</a:t>
+            </a:r>
+          </a:p>
+        </p:txBody>
+      </p:sp>
+      <p:sp>
+        <p:nvSpPr>
+          <p:cNvPr id="18" name="TextBox 17"/>
+          <p:cNvSpPr txBox="1"/>
+          <p:nvPr/>
+        </p:nvSpPr>
+        <p:spPr>
+          <a:xfrm>
+            <a:off x="822960" y="6172200"/>
+            <a:ext cx="7223760" cy="457200"/>
+          </a:xfrm>
+          <a:prstGeom prst="rect">
+            <a:avLst/>
+          </a:prstGeom>
+          <a:noFill/>
+        </p:spPr>
+        <p:txBody>
+          <a:bodyPr wrap="square" anchor="t" lIns="0" rIns="0" tIns="0" bIns="0">
+            <a:spAutoFit/>
+          </a:bodyPr>
+          <a:lstStyle/>
+          <a:p>
+            <a:pPr algn="l">
+              <a:lnSpc>
+                <a:spcPct val="100000"/>
+              </a:lnSpc>
+              <a:spcBef>
+                <a:spcPts val="0"/>
+              </a:spcBef>
+              <a:spcAft>
+                <a:spcPts val="600"/>
+              </a:spcAft>
+            </a:pPr>
+            <a:r>
+              <a:rPr sz="1250" b="0" i="0">
+                <a:solidFill>
+                  <a:srgbClr val="B9B0C8"/>
                 </a:solidFill>
                 <a:latin typeface="Segoe UI"/>
               </a:rPr>
-              <a:t>akkaverse.vercel.app   ·   github.com/Mithuncoding/akkaverse   ·   youtu.be/lXtAyZyDumM</a:t>
+              <a:t>akkaverse.vercel.app  ·  github.com/Mithuncoding/akkaverse</a:t>
             </a:r>
           </a:p>
         </p:txBody>
@@ -3619,7 +3877,7 @@
             <a:avLst/>
           </a:prstGeom>
           <a:solidFill>
-            <a:srgbClr val="0E0B16"/>
+            <a:srgbClr val="0C0A14"/>
           </a:solidFill>
           <a:ln>
             <a:noFill/>
@@ -3657,7 +3915,7 @@
         <p:spPr>
           <a:xfrm>
             <a:off x="0" y="0"/>
-            <a:ext cx="256032" cy="6858000"/>
+            <a:ext cx="237744" cy="6858000"/>
           </a:xfrm>
           <a:prstGeom prst="rect">
             <a:avLst/>
@@ -3700,8 +3958,8 @@
         </p:nvSpPr>
         <p:spPr>
           <a:xfrm>
-            <a:off x="256032" y="0"/>
-            <a:ext cx="91440" cy="6858000"/>
+            <a:off x="237744" y="0"/>
+            <a:ext cx="82296" cy="6858000"/>
           </a:xfrm>
           <a:prstGeom prst="rect">
             <a:avLst/>
@@ -3738,13 +3996,59 @@
       </p:sp>
       <p:sp>
         <p:nvSpPr>
-          <p:cNvPr id="5" name="Rectangle 4"/>
+          <p:cNvPr id="5" name="Oval 4"/>
           <p:cNvSpPr/>
           <p:nvPr/>
         </p:nvSpPr>
         <p:spPr>
           <a:xfrm>
-            <a:off x="822960" y="786384"/>
+            <a:off x="8" y="3"/>
+            <a:ext cx="5486400" cy="5486400"/>
+          </a:xfrm>
+          <a:prstGeom prst="ellipse">
+            <a:avLst/>
+          </a:prstGeom>
+          <a:solidFill>
+            <a:srgbClr val="E03E8A">
+              <a:alpha val="12000"/>
+            </a:srgbClr>
+          </a:solidFill>
+          <a:ln>
+            <a:noFill/>
+          </a:ln>
+          <a:effectLst/>
+        </p:spPr>
+        <p:style>
+          <a:lnRef idx="1">
+            <a:schemeClr val="accent1"/>
+          </a:lnRef>
+          <a:fillRef idx="3">
+            <a:schemeClr val="accent1"/>
+          </a:fillRef>
+          <a:effectRef idx="2">
+            <a:schemeClr val="accent1"/>
+          </a:effectRef>
+          <a:fontRef idx="minor">
+            <a:schemeClr val="lt1"/>
+          </a:fontRef>
+        </p:style>
+        <p:txBody>
+          <a:bodyPr rtlCol="0" anchor="ctr"/>
+          <a:lstStyle/>
+          <a:p>
+            <a:pPr algn="ctr"/>
+          </a:p>
+        </p:txBody>
+      </p:sp>
+      <p:sp>
+        <p:nvSpPr>
+          <p:cNvPr id="6" name="Rectangle 5"/>
+          <p:cNvSpPr/>
+          <p:nvPr/>
+        </p:nvSpPr>
+        <p:spPr>
+          <a:xfrm>
+            <a:off x="822960" y="822960"/>
             <a:ext cx="82296" cy="310896"/>
           </a:xfrm>
           <a:prstGeom prst="rect">
@@ -3782,13 +4086,13 @@
       </p:sp>
       <p:sp>
         <p:nvSpPr>
-          <p:cNvPr id="6" name="TextBox 5"/>
+          <p:cNvPr id="7" name="TextBox 6"/>
           <p:cNvSpPr txBox="1"/>
           <p:nvPr/>
         </p:nvSpPr>
         <p:spPr>
           <a:xfrm>
-            <a:off x="1024128" y="749808"/>
+            <a:off x="1024128" y="786384"/>
             <a:ext cx="8229600" cy="457200"/>
           </a:xfrm>
           <a:prstGeom prst="rect">
@@ -3827,14 +4131,194 @@
       </p:sp>
       <p:sp>
         <p:nvSpPr>
-          <p:cNvPr id="7" name="TextBox 6"/>
+          <p:cNvPr id="8" name="Oval 7"/>
+          <p:cNvSpPr/>
+          <p:nvPr/>
+        </p:nvSpPr>
+        <p:spPr>
+          <a:xfrm>
+            <a:off x="10218419" y="662940"/>
+            <a:ext cx="960120" cy="960120"/>
+          </a:xfrm>
+          <a:prstGeom prst="ellipse">
+            <a:avLst/>
+          </a:prstGeom>
+          <a:solidFill>
+            <a:srgbClr val="F7F2E7"/>
+          </a:solidFill>
+          <a:ln w="31750">
+            <a:solidFill>
+              <a:srgbClr val="1B4FB0"/>
+            </a:solidFill>
+          </a:ln>
+          <a:effectLst/>
+        </p:spPr>
+        <p:style>
+          <a:lnRef idx="1">
+            <a:schemeClr val="accent1"/>
+          </a:lnRef>
+          <a:fillRef idx="3">
+            <a:schemeClr val="accent1"/>
+          </a:fillRef>
+          <a:effectRef idx="2">
+            <a:schemeClr val="accent1"/>
+          </a:effectRef>
+          <a:fontRef idx="minor">
+            <a:schemeClr val="lt1"/>
+          </a:fontRef>
+        </p:style>
+        <p:txBody>
+          <a:bodyPr rtlCol="0" anchor="ctr"/>
+          <a:lstStyle/>
+          <a:p>
+            <a:pPr algn="ctr"/>
+          </a:p>
+        </p:txBody>
+      </p:sp>
+      <p:sp>
+        <p:nvSpPr>
+          <p:cNvPr id="9" name="Oval 8"/>
+          <p:cNvSpPr/>
+          <p:nvPr/>
+        </p:nvSpPr>
+        <p:spPr>
+          <a:xfrm>
+            <a:off x="10314432" y="758952"/>
+            <a:ext cx="768096" cy="768096"/>
+          </a:xfrm>
+          <a:prstGeom prst="ellipse">
+            <a:avLst/>
+          </a:prstGeom>
+          <a:noFill/>
+          <a:ln w="19050">
+            <a:solidFill>
+              <a:srgbClr val="1B4FB0"/>
+            </a:solidFill>
+          </a:ln>
+          <a:effectLst/>
+        </p:spPr>
+        <p:style>
+          <a:lnRef idx="1">
+            <a:schemeClr val="accent1"/>
+          </a:lnRef>
+          <a:fillRef idx="3">
+            <a:schemeClr val="accent1"/>
+          </a:fillRef>
+          <a:effectRef idx="2">
+            <a:schemeClr val="accent1"/>
+          </a:effectRef>
+          <a:fontRef idx="minor">
+            <a:schemeClr val="lt1"/>
+          </a:fontRef>
+        </p:style>
+        <p:txBody>
+          <a:bodyPr rtlCol="0" anchor="ctr"/>
+          <a:lstStyle/>
+          <a:p>
+            <a:pPr algn="ctr"/>
+          </a:p>
+        </p:txBody>
+      </p:sp>
+      <p:sp>
+        <p:nvSpPr>
+          <p:cNvPr id="10" name="TextBox 9"/>
           <p:cNvSpPr txBox="1"/>
           <p:nvPr/>
         </p:nvSpPr>
         <p:spPr>
           <a:xfrm>
-            <a:off x="822960" y="1234440"/>
-            <a:ext cx="10515600" cy="914400"/>
+            <a:off x="10218419" y="989380"/>
+            <a:ext cx="960120" cy="307238"/>
+          </a:xfrm>
+          <a:prstGeom prst="rect">
+            <a:avLst/>
+          </a:prstGeom>
+          <a:noFill/>
+        </p:spPr>
+        <p:txBody>
+          <a:bodyPr wrap="square" anchor="ctr" lIns="0" rIns="0" tIns="0" bIns="0">
+            <a:spAutoFit/>
+          </a:bodyPr>
+          <a:lstStyle/>
+          <a:p>
+            <a:pPr algn="ctr">
+              <a:lnSpc>
+                <a:spcPct val="100000"/>
+              </a:lnSpc>
+              <a:spcBef>
+                <a:spcPts val="0"/>
+              </a:spcBef>
+              <a:spcAft>
+                <a:spcPts val="0"/>
+              </a:spcAft>
+            </a:pPr>
+            <a:r>
+              <a:rPr sz="1500" b="1" i="0">
+                <a:solidFill>
+                  <a:srgbClr val="C8272B"/>
+                </a:solidFill>
+                <a:latin typeface="Georgia"/>
+              </a:rPr>
+              <a:t>ಅಕ್ಕ</a:t>
+            </a:r>
+          </a:p>
+        </p:txBody>
+      </p:sp>
+      <p:sp>
+        <p:nvSpPr>
+          <p:cNvPr id="11" name="TextBox 10"/>
+          <p:cNvSpPr txBox="1"/>
+          <p:nvPr/>
+        </p:nvSpPr>
+        <p:spPr>
+          <a:xfrm>
+            <a:off x="10218419" y="1239012"/>
+            <a:ext cx="960120" cy="249631"/>
+          </a:xfrm>
+          <a:prstGeom prst="rect">
+            <a:avLst/>
+          </a:prstGeom>
+          <a:noFill/>
+        </p:spPr>
+        <p:txBody>
+          <a:bodyPr wrap="square" anchor="ctr" lIns="0" rIns="0" tIns="0" bIns="0">
+            <a:spAutoFit/>
+          </a:bodyPr>
+          <a:lstStyle/>
+          <a:p>
+            <a:pPr algn="ctr">
+              <a:lnSpc>
+                <a:spcPct val="100000"/>
+              </a:lnSpc>
+              <a:spcBef>
+                <a:spcPts val="0"/>
+              </a:spcBef>
+              <a:spcAft>
+                <a:spcPts val="0"/>
+              </a:spcAft>
+            </a:pPr>
+            <a:r>
+              <a:rPr sz="1100" b="1" i="0">
+                <a:solidFill>
+                  <a:srgbClr val="1B4FB0"/>
+                </a:solidFill>
+                <a:latin typeface="Segoe UI"/>
+              </a:rPr>
+              <a:t>AKKA</a:t>
+            </a:r>
+          </a:p>
+        </p:txBody>
+      </p:sp>
+      <p:sp>
+        <p:nvSpPr>
+          <p:cNvPr id="12" name="TextBox 11"/>
+          <p:cNvSpPr txBox="1"/>
+          <p:nvPr/>
+        </p:nvSpPr>
+        <p:spPr>
+          <a:xfrm>
+            <a:off x="822960" y="1188720"/>
+            <a:ext cx="8686800" cy="914400"/>
           </a:xfrm>
           <a:prstGeom prst="rect">
             <a:avLst/>
@@ -3859,7 +4343,7 @@
               </a:spcAft>
             </a:pPr>
             <a:r>
-              <a:rPr sz="3800" b="1" i="0">
+              <a:rPr sz="3600" b="1" i="0">
                 <a:solidFill>
                   <a:srgbClr val="F7F2E7"/>
                 </a:solidFill>
@@ -3872,13 +4356,13 @@
       </p:sp>
       <p:sp>
         <p:nvSpPr>
-          <p:cNvPr id="8" name="Oval 7"/>
+          <p:cNvPr id="13" name="Oval 12"/>
           <p:cNvSpPr/>
           <p:nvPr/>
         </p:nvSpPr>
         <p:spPr>
           <a:xfrm>
-            <a:off x="914400" y="2615184"/>
+            <a:off x="914400" y="2368296"/>
             <a:ext cx="182880" cy="182880"/>
           </a:xfrm>
           <a:prstGeom prst="ellipse">
@@ -3916,14 +4400,14 @@
       </p:sp>
       <p:sp>
         <p:nvSpPr>
-          <p:cNvPr id="9" name="TextBox 8"/>
+          <p:cNvPr id="14" name="TextBox 13"/>
           <p:cNvSpPr txBox="1"/>
           <p:nvPr/>
         </p:nvSpPr>
         <p:spPr>
           <a:xfrm>
-            <a:off x="1280160" y="2468880"/>
-            <a:ext cx="3657600" cy="548640"/>
+            <a:off x="1280160" y="2240280"/>
+            <a:ext cx="3749039" cy="548640"/>
           </a:xfrm>
           <a:prstGeom prst="rect">
             <a:avLst/>
@@ -3948,7 +4432,7 @@
               </a:spcAft>
             </a:pPr>
             <a:r>
-              <a:rPr sz="1700" b="1" i="0">
+              <a:rPr sz="1600" b="1" i="0">
                 <a:solidFill>
                   <a:srgbClr val="F7F2E7"/>
                 </a:solidFill>
@@ -3961,14 +4445,14 @@
       </p:sp>
       <p:sp>
         <p:nvSpPr>
-          <p:cNvPr id="10" name="TextBox 9"/>
+          <p:cNvPr id="15" name="TextBox 14"/>
           <p:cNvSpPr txBox="1"/>
           <p:nvPr/>
         </p:nvSpPr>
         <p:spPr>
           <a:xfrm>
-            <a:off x="4937760" y="2468880"/>
-            <a:ext cx="6309360" cy="548640"/>
+            <a:off x="5029200" y="2240280"/>
+            <a:ext cx="6217920" cy="548640"/>
           </a:xfrm>
           <a:prstGeom prst="rect">
             <a:avLst/>
@@ -3993,7 +4477,7 @@
               </a:spcAft>
             </a:pPr>
             <a:r>
-              <a:rPr sz="1500" b="0" i="0">
+              <a:rPr sz="1400" b="0" i="0">
                 <a:solidFill>
                   <a:srgbClr val="B9B0C8"/>
                 </a:solidFill>
@@ -4006,13 +4490,13 @@
       </p:sp>
       <p:sp>
         <p:nvSpPr>
-          <p:cNvPr id="11" name="Oval 10"/>
+          <p:cNvPr id="16" name="Oval 15"/>
           <p:cNvSpPr/>
           <p:nvPr/>
         </p:nvSpPr>
         <p:spPr>
           <a:xfrm>
-            <a:off x="914400" y="3182112"/>
+            <a:off x="914400" y="2880360"/>
             <a:ext cx="182880" cy="182880"/>
           </a:xfrm>
           <a:prstGeom prst="ellipse">
@@ -4050,14 +4534,14 @@
       </p:sp>
       <p:sp>
         <p:nvSpPr>
-          <p:cNvPr id="12" name="TextBox 11"/>
+          <p:cNvPr id="17" name="TextBox 16"/>
           <p:cNvSpPr txBox="1"/>
           <p:nvPr/>
         </p:nvSpPr>
         <p:spPr>
           <a:xfrm>
-            <a:off x="1280160" y="3035808"/>
-            <a:ext cx="3657600" cy="548640"/>
+            <a:off x="1280160" y="2752344"/>
+            <a:ext cx="3749039" cy="548640"/>
           </a:xfrm>
           <a:prstGeom prst="rect">
             <a:avLst/>
@@ -4082,7 +4566,7 @@
               </a:spcAft>
             </a:pPr>
             <a:r>
-              <a:rPr sz="1700" b="1" i="0">
+              <a:rPr sz="1600" b="1" i="0">
                 <a:solidFill>
                   <a:srgbClr val="F7F2E7"/>
                 </a:solidFill>
@@ -4095,14 +4579,14 @@
       </p:sp>
       <p:sp>
         <p:nvSpPr>
-          <p:cNvPr id="13" name="TextBox 12"/>
+          <p:cNvPr id="18" name="TextBox 17"/>
           <p:cNvSpPr txBox="1"/>
           <p:nvPr/>
         </p:nvSpPr>
         <p:spPr>
           <a:xfrm>
-            <a:off x="4937760" y="3035808"/>
-            <a:ext cx="6309360" cy="548640"/>
+            <a:off x="5029200" y="2752344"/>
+            <a:ext cx="6217920" cy="548640"/>
           </a:xfrm>
           <a:prstGeom prst="rect">
             <a:avLst/>
@@ -4127,7 +4611,7 @@
               </a:spcAft>
             </a:pPr>
             <a:r>
-              <a:rPr sz="1500" b="0" i="0">
+              <a:rPr sz="1400" b="0" i="0">
                 <a:solidFill>
                   <a:srgbClr val="B9B0C8"/>
                 </a:solidFill>
@@ -4140,13 +4624,13 @@
       </p:sp>
       <p:sp>
         <p:nvSpPr>
-          <p:cNvPr id="14" name="Oval 13"/>
+          <p:cNvPr id="19" name="Oval 18"/>
           <p:cNvSpPr/>
           <p:nvPr/>
         </p:nvSpPr>
         <p:spPr>
           <a:xfrm>
-            <a:off x="914400" y="3749040"/>
+            <a:off x="914400" y="3392424"/>
             <a:ext cx="182880" cy="182880"/>
           </a:xfrm>
           <a:prstGeom prst="ellipse">
@@ -4184,14 +4668,14 @@
       </p:sp>
       <p:sp>
         <p:nvSpPr>
-          <p:cNvPr id="15" name="TextBox 14"/>
+          <p:cNvPr id="20" name="TextBox 19"/>
           <p:cNvSpPr txBox="1"/>
           <p:nvPr/>
         </p:nvSpPr>
         <p:spPr>
           <a:xfrm>
-            <a:off x="1280160" y="3602736"/>
-            <a:ext cx="3657600" cy="548640"/>
+            <a:off x="1280160" y="3264408"/>
+            <a:ext cx="3749039" cy="548640"/>
           </a:xfrm>
           <a:prstGeom prst="rect">
             <a:avLst/>
@@ -4216,7 +4700,7 @@
               </a:spcAft>
             </a:pPr>
             <a:r>
-              <a:rPr sz="1700" b="1" i="0">
+              <a:rPr sz="1600" b="1" i="0">
                 <a:solidFill>
                   <a:srgbClr val="F7F2E7"/>
                 </a:solidFill>
@@ -4229,14 +4713,14 @@
       </p:sp>
       <p:sp>
         <p:nvSpPr>
-          <p:cNvPr id="16" name="TextBox 15"/>
+          <p:cNvPr id="21" name="TextBox 20"/>
           <p:cNvSpPr txBox="1"/>
           <p:nvPr/>
         </p:nvSpPr>
         <p:spPr>
           <a:xfrm>
-            <a:off x="4937760" y="3602736"/>
-            <a:ext cx="6309360" cy="548640"/>
+            <a:off x="5029200" y="3264408"/>
+            <a:ext cx="6217920" cy="548640"/>
           </a:xfrm>
           <a:prstGeom prst="rect">
             <a:avLst/>
@@ -4261,26 +4745,26 @@
               </a:spcAft>
             </a:pPr>
             <a:r>
-              <a:rPr sz="1500" b="0" i="0">
+              <a:rPr sz="1400" b="0" i="0">
                 <a:solidFill>
                   <a:srgbClr val="B9B0C8"/>
                 </a:solidFill>
                 <a:latin typeface="Segoe UI"/>
               </a:rPr>
-              <a:t>Moderated public archive of shared voices.</a:t>
-            </a:r>
-          </a:p>
-        </p:txBody>
-      </p:sp>
-      <p:sp>
-        <p:nvSpPr>
-          <p:cNvPr id="17" name="Oval 16"/>
+              <a:t>A moderated public archive of shared voices.</a:t>
+            </a:r>
+          </a:p>
+        </p:txBody>
+      </p:sp>
+      <p:sp>
+        <p:nvSpPr>
+          <p:cNvPr id="22" name="Oval 21"/>
           <p:cNvSpPr/>
           <p:nvPr/>
         </p:nvSpPr>
         <p:spPr>
           <a:xfrm>
-            <a:off x="914400" y="4315968"/>
+            <a:off x="914400" y="3904488"/>
             <a:ext cx="182880" cy="182880"/>
           </a:xfrm>
           <a:prstGeom prst="ellipse">
@@ -4318,14 +4802,14 @@
       </p:sp>
       <p:sp>
         <p:nvSpPr>
-          <p:cNvPr id="18" name="TextBox 17"/>
+          <p:cNvPr id="23" name="TextBox 22"/>
           <p:cNvSpPr txBox="1"/>
           <p:nvPr/>
         </p:nvSpPr>
         <p:spPr>
           <a:xfrm>
-            <a:off x="1280160" y="4169664"/>
-            <a:ext cx="3657600" cy="548640"/>
+            <a:off x="1280160" y="3776472"/>
+            <a:ext cx="3749039" cy="548640"/>
           </a:xfrm>
           <a:prstGeom prst="rect">
             <a:avLst/>
@@ -4350,7 +4834,7 @@
               </a:spcAft>
             </a:pPr>
             <a:r>
-              <a:rPr sz="1700" b="1" i="0">
+              <a:rPr sz="1600" b="1" i="0">
                 <a:solidFill>
                   <a:srgbClr val="F7F2E7"/>
                 </a:solidFill>
@@ -4363,14 +4847,14 @@
       </p:sp>
       <p:sp>
         <p:nvSpPr>
-          <p:cNvPr id="19" name="TextBox 18"/>
+          <p:cNvPr id="24" name="TextBox 23"/>
           <p:cNvSpPr txBox="1"/>
           <p:nvPr/>
         </p:nvSpPr>
         <p:spPr>
           <a:xfrm>
-            <a:off x="4937760" y="4169664"/>
-            <a:ext cx="6309360" cy="548640"/>
+            <a:off x="5029200" y="3776472"/>
+            <a:ext cx="6217920" cy="548640"/>
           </a:xfrm>
           <a:prstGeom prst="rect">
             <a:avLst/>
@@ -4395,7 +4879,7 @@
               </a:spcAft>
             </a:pPr>
             <a:r>
-              <a:rPr sz="1500" b="0" i="0">
+              <a:rPr sz="1400" b="0" i="0">
                 <a:solidFill>
                   <a:srgbClr val="B9B0C8"/>
                 </a:solidFill>
@@ -4408,13 +4892,13 @@
       </p:sp>
       <p:sp>
         <p:nvSpPr>
-          <p:cNvPr id="20" name="Oval 19"/>
+          <p:cNvPr id="25" name="Oval 24"/>
           <p:cNvSpPr/>
           <p:nvPr/>
         </p:nvSpPr>
         <p:spPr>
           <a:xfrm>
-            <a:off x="914400" y="4882896"/>
+            <a:off x="914400" y="4416552"/>
             <a:ext cx="182880" cy="182880"/>
           </a:xfrm>
           <a:prstGeom prst="ellipse">
@@ -4452,14 +4936,14 @@
       </p:sp>
       <p:sp>
         <p:nvSpPr>
-          <p:cNvPr id="21" name="TextBox 20"/>
+          <p:cNvPr id="26" name="TextBox 25"/>
           <p:cNvSpPr txBox="1"/>
           <p:nvPr/>
         </p:nvSpPr>
         <p:spPr>
           <a:xfrm>
-            <a:off x="1280160" y="4736592"/>
-            <a:ext cx="3657600" cy="548640"/>
+            <a:off x="1280160" y="4288536"/>
+            <a:ext cx="3749039" cy="548640"/>
           </a:xfrm>
           <a:prstGeom prst="rect">
             <a:avLst/>
@@ -4484,7 +4968,7 @@
               </a:spcAft>
             </a:pPr>
             <a:r>
-              <a:rPr sz="1700" b="1" i="0">
+              <a:rPr sz="1600" b="1" i="0">
                 <a:solidFill>
                   <a:srgbClr val="F7F2E7"/>
                 </a:solidFill>
@@ -4497,14 +4981,14 @@
       </p:sp>
       <p:sp>
         <p:nvSpPr>
-          <p:cNvPr id="22" name="TextBox 21"/>
+          <p:cNvPr id="27" name="TextBox 26"/>
           <p:cNvSpPr txBox="1"/>
           <p:nvPr/>
         </p:nvSpPr>
         <p:spPr>
           <a:xfrm>
-            <a:off x="4937760" y="4736592"/>
-            <a:ext cx="6309360" cy="548640"/>
+            <a:off x="5029200" y="4288536"/>
+            <a:ext cx="6217920" cy="548640"/>
           </a:xfrm>
           <a:prstGeom prst="rect">
             <a:avLst/>
@@ -4529,7 +5013,7 @@
               </a:spcAft>
             </a:pPr>
             <a:r>
-              <a:rPr sz="1500" b="0" i="0">
+              <a:rPr sz="1400" b="0" i="0">
                 <a:solidFill>
                   <a:srgbClr val="B9B0C8"/>
                 </a:solidFill>
@@ -4542,14 +5026,14 @@
       </p:sp>
       <p:sp>
         <p:nvSpPr>
-          <p:cNvPr id="23" name="Rounded Rectangle 22"/>
+          <p:cNvPr id="28" name="Rounded Rectangle 27"/>
           <p:cNvSpPr/>
           <p:nvPr/>
         </p:nvSpPr>
         <p:spPr>
           <a:xfrm>
-            <a:off x="822960" y="5532120"/>
-            <a:ext cx="10515600" cy="914400"/>
+            <a:off x="822960" y="4956048"/>
+            <a:ext cx="10543032" cy="1335024"/>
           </a:xfrm>
           <a:prstGeom prst="roundRect">
             <a:avLst>
@@ -4588,14 +5072,14 @@
       </p:sp>
       <p:sp>
         <p:nvSpPr>
-          <p:cNvPr id="24" name="TextBox 23"/>
+          <p:cNvPr id="29" name="TextBox 28"/>
           <p:cNvSpPr txBox="1"/>
           <p:nvPr/>
         </p:nvSpPr>
         <p:spPr>
           <a:xfrm>
-            <a:off x="1143000" y="5550408"/>
-            <a:ext cx="10058400" cy="914400"/>
+            <a:off x="1143000" y="5102352"/>
+            <a:ext cx="10058400" cy="457200"/>
           </a:xfrm>
           <a:prstGeom prst="rect">
             <a:avLst/>
@@ -4603,7 +5087,7 @@
           <a:noFill/>
         </p:spPr>
         <p:txBody>
-          <a:bodyPr wrap="square" anchor="ctr" lIns="0" rIns="0" tIns="0" bIns="0">
+          <a:bodyPr wrap="square" anchor="t" lIns="0" rIns="0" tIns="0" bIns="0">
             <a:spAutoFit/>
           </a:bodyPr>
           <a:lstStyle/>
@@ -4616,17 +5100,129 @@
                 <a:spcPts val="0"/>
               </a:spcBef>
               <a:spcAft>
+                <a:spcPts val="0"/>
+              </a:spcAft>
+            </a:pPr>
+            <a:r>
+              <a:rPr sz="1900" b="1" i="0">
+                <a:solidFill>
+                  <a:srgbClr val="FF9F1C"/>
+                </a:solidFill>
+                <a:latin typeface="Georgia"/>
+              </a:rPr>
+              <a:t>Thank you.</a:t>
+            </a:r>
+          </a:p>
+          <a:p>
+            <a:pPr algn="l">
+              <a:lnSpc>
+                <a:spcPct val="100000"/>
+              </a:lnSpc>
+              <a:spcBef>
+                <a:spcPts val="0"/>
+              </a:spcBef>
+              <a:spcAft>
+                <a:spcPts val="0"/>
+              </a:spcAft>
+            </a:pPr>
+            <a:r>
+              <a:rPr sz="1500" b="0" i="0">
+                <a:solidFill>
+                  <a:srgbClr val="F7F2E7"/>
+                </a:solidFill>
+                <a:latin typeface="Segoe UI"/>
+              </a:rPr>
+              <a:t>   Let's keep every family's voice alive.</a:t>
+            </a:r>
+          </a:p>
+        </p:txBody>
+      </p:sp>
+      <p:sp>
+        <p:nvSpPr>
+          <p:cNvPr id="30" name="TextBox 29"/>
+          <p:cNvSpPr txBox="1"/>
+          <p:nvPr/>
+        </p:nvSpPr>
+        <p:spPr>
+          <a:xfrm>
+            <a:off x="1143000" y="5797296"/>
+            <a:ext cx="10058400" cy="457200"/>
+          </a:xfrm>
+          <a:prstGeom prst="rect">
+            <a:avLst/>
+          </a:prstGeom>
+          <a:noFill/>
+        </p:spPr>
+        <p:txBody>
+          <a:bodyPr wrap="square" anchor="t" lIns="0" rIns="0" tIns="0" bIns="0">
+            <a:spAutoFit/>
+          </a:bodyPr>
+          <a:lstStyle/>
+          <a:p>
+            <a:pPr algn="l">
+              <a:lnSpc>
+                <a:spcPct val="100000"/>
+              </a:lnSpc>
+              <a:spcBef>
+                <a:spcPts val="0"/>
+              </a:spcBef>
+              <a:spcAft>
                 <a:spcPts val="600"/>
               </a:spcAft>
             </a:pPr>
             <a:r>
-              <a:rPr sz="1600" b="1" i="0">
-                <a:solidFill>
-                  <a:srgbClr val="FF9F1C"/>
+              <a:rPr sz="1300" b="0" i="0">
+                <a:solidFill>
+                  <a:srgbClr val="B9B0C8"/>
                 </a:solidFill>
                 <a:latin typeface="Segoe UI"/>
               </a:rPr>
-              <a:t>The ask:  a pilot with a Kannada school or cultural association — and support to bring family heritage preservation to every diaspora home.</a:t>
+              <a:t>Live  akkaverse.vercel.app      ·      Code  github.com/Mithuncoding/akkaverse      ·      Video  youtu.be/lXtAyZyDumM</a:t>
+            </a:r>
+          </a:p>
+        </p:txBody>
+      </p:sp>
+      <p:sp>
+        <p:nvSpPr>
+          <p:cNvPr id="31" name="TextBox 30"/>
+          <p:cNvSpPr txBox="1"/>
+          <p:nvPr/>
+        </p:nvSpPr>
+        <p:spPr>
+          <a:xfrm>
+            <a:off x="822960" y="6473952"/>
+            <a:ext cx="10543032" cy="320040"/>
+          </a:xfrm>
+          <a:prstGeom prst="rect">
+            <a:avLst/>
+          </a:prstGeom>
+          <a:noFill/>
+        </p:spPr>
+        <p:txBody>
+          <a:bodyPr wrap="square" anchor="t" lIns="0" rIns="0" tIns="0" bIns="0">
+            <a:spAutoFit/>
+          </a:bodyPr>
+          <a:lstStyle/>
+          <a:p>
+            <a:pPr algn="ctr">
+              <a:lnSpc>
+                <a:spcPct val="100000"/>
+              </a:lnSpc>
+              <a:spcBef>
+                <a:spcPts val="0"/>
+              </a:spcBef>
+              <a:spcAft>
+                <a:spcPts val="600"/>
+              </a:spcAft>
+            </a:pPr>
+            <a:r>
+              <a:rPr sz="1200" b="1" i="0">
+                <a:solidFill>
+                  <a:srgbClr val="B9B0C8"/>
+                </a:solidFill>
+                <a:latin typeface="Segoe UI"/>
+              </a:rPr>
+              <a:t>ಅಕ್ಕ  Akkaverse  ·  Built by Mithun R</a:t>
             </a:r>
           </a:p>
         </p:txBody>
@@ -4664,7 +5260,7 @@
             <a:avLst/>
           </a:prstGeom>
           <a:solidFill>
-            <a:srgbClr val="0E0B16"/>
+            <a:srgbClr val="0C0A14"/>
           </a:solidFill>
           <a:ln>
             <a:noFill/>
@@ -4701,7 +5297,7 @@
         </p:nvSpPr>
         <p:spPr>
           <a:xfrm>
-            <a:off x="822960" y="786384"/>
+            <a:off x="822960" y="822960"/>
             <a:ext cx="82296" cy="310896"/>
           </a:xfrm>
           <a:prstGeom prst="rect">
@@ -4745,7 +5341,7 @@
         </p:nvSpPr>
         <p:spPr>
           <a:xfrm>
-            <a:off x="1024128" y="749808"/>
+            <a:off x="1024128" y="786384"/>
             <a:ext cx="8229600" cy="457200"/>
           </a:xfrm>
           <a:prstGeom prst="rect">
@@ -4790,7 +5386,7 @@
         </p:nvSpPr>
         <p:spPr>
           <a:xfrm>
-            <a:off x="822960" y="1234440"/>
+            <a:off x="822960" y="1188720"/>
             <a:ext cx="10515600" cy="1280160"/>
           </a:xfrm>
           <a:prstGeom prst="rect">
@@ -4816,13 +5412,13 @@
               </a:spcAft>
             </a:pPr>
             <a:r>
-              <a:rPr sz="3800" b="1" i="0">
+              <a:rPr sz="3600" b="1" i="0">
                 <a:solidFill>
                   <a:srgbClr val="F7F2E7"/>
                 </a:solidFill>
                 <a:latin typeface="Georgia"/>
               </a:rPr>
-              <a:t>Culture doesn't disappear overnight.
+              <a:t>Culture doesn't vanish overnight.
 It fades one generation at a time.</a:t>
             </a:r>
           </a:p>
@@ -4836,8 +5432,8 @@
         </p:nvSpPr>
         <p:spPr>
           <a:xfrm>
-            <a:off x="822960" y="2926080"/>
-            <a:ext cx="3383280" cy="2286000"/>
+            <a:off x="822960" y="2880360"/>
+            <a:ext cx="3383280" cy="2240280"/>
           </a:xfrm>
           <a:prstGeom prst="roundRect">
             <a:avLst>
@@ -4882,7 +5478,7 @@
         </p:nvSpPr>
         <p:spPr>
           <a:xfrm>
-            <a:off x="822960" y="2926080"/>
+            <a:off x="822960" y="2880360"/>
             <a:ext cx="3383280" cy="128016"/>
           </a:xfrm>
           <a:prstGeom prst="rect">
@@ -4926,7 +5522,7 @@
         </p:nvSpPr>
         <p:spPr>
           <a:xfrm>
-            <a:off x="1115568" y="3246120"/>
+            <a:off x="1115568" y="3200400"/>
             <a:ext cx="2834640" cy="640080"/>
           </a:xfrm>
           <a:prstGeom prst="rect">
@@ -4971,7 +5567,7 @@
         </p:nvSpPr>
         <p:spPr>
           <a:xfrm>
-            <a:off x="1115568" y="3931920"/>
+            <a:off x="1115568" y="3877056"/>
             <a:ext cx="2834640" cy="548640"/>
           </a:xfrm>
           <a:prstGeom prst="rect">
@@ -5016,7 +5612,7 @@
         </p:nvSpPr>
         <p:spPr>
           <a:xfrm>
-            <a:off x="1115568" y="4526280"/>
+            <a:off x="1115568" y="4462272"/>
             <a:ext cx="2834640" cy="731520"/>
           </a:xfrm>
           <a:prstGeom prst="rect">
@@ -5061,8 +5657,8 @@
         </p:nvSpPr>
         <p:spPr>
           <a:xfrm>
-            <a:off x="4434840" y="2926080"/>
-            <a:ext cx="3383280" cy="2286000"/>
+            <a:off x="4434840" y="2880360"/>
+            <a:ext cx="3383280" cy="2240280"/>
           </a:xfrm>
           <a:prstGeom prst="roundRect">
             <a:avLst>
@@ -5107,7 +5703,7 @@
         </p:nvSpPr>
         <p:spPr>
           <a:xfrm>
-            <a:off x="4434840" y="2926080"/>
+            <a:off x="4434840" y="2880360"/>
             <a:ext cx="3383280" cy="128016"/>
           </a:xfrm>
           <a:prstGeom prst="rect">
@@ -5151,7 +5747,7 @@
         </p:nvSpPr>
         <p:spPr>
           <a:xfrm>
-            <a:off x="4727448" y="3246120"/>
+            <a:off x="4727448" y="3200400"/>
             <a:ext cx="2834640" cy="640080"/>
           </a:xfrm>
           <a:prstGeom prst="rect">
@@ -5196,7 +5792,7 @@
         </p:nvSpPr>
         <p:spPr>
           <a:xfrm>
-            <a:off x="4727448" y="3931920"/>
+            <a:off x="4727448" y="3877056"/>
             <a:ext cx="2834640" cy="548640"/>
           </a:xfrm>
           <a:prstGeom prst="rect">
@@ -5241,7 +5837,7 @@
         </p:nvSpPr>
         <p:spPr>
           <a:xfrm>
-            <a:off x="4727448" y="4526280"/>
+            <a:off x="4727448" y="4462272"/>
             <a:ext cx="2834640" cy="731520"/>
           </a:xfrm>
           <a:prstGeom prst="rect">
@@ -5286,8 +5882,8 @@
         </p:nvSpPr>
         <p:spPr>
           <a:xfrm>
-            <a:off x="8046720" y="2926080"/>
-            <a:ext cx="3383280" cy="2286000"/>
+            <a:off x="8046720" y="2880360"/>
+            <a:ext cx="3383280" cy="2240280"/>
           </a:xfrm>
           <a:prstGeom prst="roundRect">
             <a:avLst>
@@ -5332,7 +5928,7 @@
         </p:nvSpPr>
         <p:spPr>
           <a:xfrm>
-            <a:off x="8046720" y="2926080"/>
+            <a:off x="8046720" y="2880360"/>
             <a:ext cx="3383280" cy="128016"/>
           </a:xfrm>
           <a:prstGeom prst="rect">
@@ -5376,7 +5972,7 @@
         </p:nvSpPr>
         <p:spPr>
           <a:xfrm>
-            <a:off x="8339328" y="3246120"/>
+            <a:off x="8339328" y="3200400"/>
             <a:ext cx="2834640" cy="640080"/>
           </a:xfrm>
           <a:prstGeom prst="rect">
@@ -5421,7 +6017,7 @@
         </p:nvSpPr>
         <p:spPr>
           <a:xfrm>
-            <a:off x="8339328" y="3931920"/>
+            <a:off x="8339328" y="3877056"/>
             <a:ext cx="2834640" cy="548640"/>
           </a:xfrm>
           <a:prstGeom prst="rect">
@@ -5466,7 +6062,7 @@
         </p:nvSpPr>
         <p:spPr>
           <a:xfrm>
-            <a:off x="8339328" y="4526280"/>
+            <a:off x="8339328" y="4462272"/>
             <a:ext cx="2834640" cy="731520"/>
           </a:xfrm>
           <a:prstGeom prst="rect">
@@ -5511,8 +6107,8 @@
         </p:nvSpPr>
         <p:spPr>
           <a:xfrm>
-            <a:off x="822960" y="5623560"/>
-            <a:ext cx="10515600" cy="914400"/>
+            <a:off x="822960" y="5486400"/>
+            <a:ext cx="10515600" cy="868680"/>
           </a:xfrm>
           <a:prstGeom prst="rect">
             <a:avLst/>
@@ -5544,6 +6140,185 @@
                 <a:latin typeface="Segoe UI"/>
               </a:rPr>
               <a:t>When an elder is gone, their voice, blessings, proverbs, recipes and stories go too. Existing heritage apps are static encyclopedias — they store facts, not living family memory.</a:t>
+            </a:r>
+          </a:p>
+        </p:txBody>
+      </p:sp>
+      <p:sp>
+        <p:nvSpPr>
+          <p:cNvPr id="22" name="Rectangle 21"/>
+          <p:cNvSpPr/>
+          <p:nvPr/>
+        </p:nvSpPr>
+        <p:spPr>
+          <a:xfrm>
+            <a:off x="822960" y="6419088"/>
+            <a:ext cx="10543032" cy="12801"/>
+          </a:xfrm>
+          <a:prstGeom prst="rect">
+            <a:avLst/>
+          </a:prstGeom>
+          <a:solidFill>
+            <a:srgbClr val="1A142C"/>
+          </a:solidFill>
+          <a:ln>
+            <a:noFill/>
+          </a:ln>
+          <a:effectLst/>
+        </p:spPr>
+        <p:style>
+          <a:lnRef idx="1">
+            <a:schemeClr val="accent1"/>
+          </a:lnRef>
+          <a:fillRef idx="3">
+            <a:schemeClr val="accent1"/>
+          </a:fillRef>
+          <a:effectRef idx="2">
+            <a:schemeClr val="accent1"/>
+          </a:effectRef>
+          <a:fontRef idx="minor">
+            <a:schemeClr val="lt1"/>
+          </a:fontRef>
+        </p:style>
+        <p:txBody>
+          <a:bodyPr rtlCol="0" anchor="ctr"/>
+          <a:lstStyle/>
+          <a:p>
+            <a:pPr algn="ctr"/>
+          </a:p>
+        </p:txBody>
+      </p:sp>
+      <p:sp>
+        <p:nvSpPr>
+          <p:cNvPr id="23" name="TextBox 22"/>
+          <p:cNvSpPr txBox="1"/>
+          <p:nvPr/>
+        </p:nvSpPr>
+        <p:spPr>
+          <a:xfrm>
+            <a:off x="822960" y="6473952"/>
+            <a:ext cx="6400800" cy="320040"/>
+          </a:xfrm>
+          <a:prstGeom prst="rect">
+            <a:avLst/>
+          </a:prstGeom>
+          <a:noFill/>
+        </p:spPr>
+        <p:txBody>
+          <a:bodyPr wrap="square" anchor="t" lIns="0" rIns="0" tIns="0" bIns="0">
+            <a:spAutoFit/>
+          </a:bodyPr>
+          <a:lstStyle/>
+          <a:p>
+            <a:pPr algn="l">
+              <a:lnSpc>
+                <a:spcPct val="100000"/>
+              </a:lnSpc>
+              <a:spcBef>
+                <a:spcPts val="0"/>
+              </a:spcBef>
+              <a:spcAft>
+                <a:spcPts val="600"/>
+              </a:spcAft>
+            </a:pPr>
+            <a:r>
+              <a:rPr sz="1100" b="1" i="0">
+                <a:solidFill>
+                  <a:srgbClr val="B9B0C8"/>
+                </a:solidFill>
+                <a:latin typeface="Segoe UI"/>
+              </a:rPr>
+              <a:t>ಅಕ್ಕ  Akkaverse</a:t>
+            </a:r>
+          </a:p>
+        </p:txBody>
+      </p:sp>
+      <p:sp>
+        <p:nvSpPr>
+          <p:cNvPr id="24" name="TextBox 23"/>
+          <p:cNvSpPr txBox="1"/>
+          <p:nvPr/>
+        </p:nvSpPr>
+        <p:spPr>
+          <a:xfrm>
+            <a:off x="5486400" y="6473952"/>
+            <a:ext cx="3657600" cy="320040"/>
+          </a:xfrm>
+          <a:prstGeom prst="rect">
+            <a:avLst/>
+          </a:prstGeom>
+          <a:noFill/>
+        </p:spPr>
+        <p:txBody>
+          <a:bodyPr wrap="square" anchor="t" lIns="0" rIns="0" tIns="0" bIns="0">
+            <a:spAutoFit/>
+          </a:bodyPr>
+          <a:lstStyle/>
+          <a:p>
+            <a:pPr algn="ctr">
+              <a:lnSpc>
+                <a:spcPct val="100000"/>
+              </a:lnSpc>
+              <a:spcBef>
+                <a:spcPts val="0"/>
+              </a:spcBef>
+              <a:spcAft>
+                <a:spcPts val="600"/>
+              </a:spcAft>
+            </a:pPr>
+            <a:r>
+              <a:rPr sz="1100" b="0" i="0">
+                <a:solidFill>
+                  <a:srgbClr val="B9B0C8"/>
+                </a:solidFill>
+                <a:latin typeface="Segoe UI"/>
+              </a:rPr>
+              <a:t>Built by Mithun R</a:t>
+            </a:r>
+          </a:p>
+        </p:txBody>
+      </p:sp>
+      <p:sp>
+        <p:nvSpPr>
+          <p:cNvPr id="25" name="TextBox 24"/>
+          <p:cNvSpPr txBox="1"/>
+          <p:nvPr/>
+        </p:nvSpPr>
+        <p:spPr>
+          <a:xfrm>
+            <a:off x="9509760" y="6473952"/>
+            <a:ext cx="1856231" cy="320040"/>
+          </a:xfrm>
+          <a:prstGeom prst="rect">
+            <a:avLst/>
+          </a:prstGeom>
+          <a:noFill/>
+        </p:spPr>
+        <p:txBody>
+          <a:bodyPr wrap="square" anchor="t" lIns="0" rIns="0" tIns="0" bIns="0">
+            <a:spAutoFit/>
+          </a:bodyPr>
+          <a:lstStyle/>
+          <a:p>
+            <a:pPr algn="r">
+              <a:lnSpc>
+                <a:spcPct val="100000"/>
+              </a:lnSpc>
+              <a:spcBef>
+                <a:spcPts val="0"/>
+              </a:spcBef>
+              <a:spcAft>
+                <a:spcPts val="600"/>
+              </a:spcAft>
+            </a:pPr>
+            <a:r>
+              <a:rPr sz="1100" b="1" i="0">
+                <a:solidFill>
+                  <a:srgbClr val="FF9F1C"/>
+                </a:solidFill>
+                <a:latin typeface="Segoe UI"/>
+              </a:rPr>
+              <a:t>02 / 10</a:t>
             </a:r>
           </a:p>
         </p:txBody>
@@ -5581,7 +6356,7 @@
             <a:avLst/>
           </a:prstGeom>
           <a:solidFill>
-            <a:srgbClr val="0E0B16"/>
+            <a:srgbClr val="0C0A14"/>
           </a:solidFill>
           <a:ln>
             <a:noFill/>
@@ -5618,7 +6393,7 @@
         </p:nvSpPr>
         <p:spPr>
           <a:xfrm>
-            <a:off x="822960" y="786384"/>
+            <a:off x="822960" y="822960"/>
             <a:ext cx="82296" cy="310896"/>
           </a:xfrm>
           <a:prstGeom prst="rect">
@@ -5662,7 +6437,7 @@
         </p:nvSpPr>
         <p:spPr>
           <a:xfrm>
-            <a:off x="1024128" y="749808"/>
+            <a:off x="1024128" y="786384"/>
             <a:ext cx="8229600" cy="457200"/>
           </a:xfrm>
           <a:prstGeom prst="rect">
@@ -5707,8 +6482,8 @@
         </p:nvSpPr>
         <p:spPr>
           <a:xfrm>
-            <a:off x="822960" y="1234440"/>
-            <a:ext cx="10515600" cy="1097280"/>
+            <a:off x="822960" y="1188720"/>
+            <a:ext cx="10515600" cy="1005840"/>
           </a:xfrm>
           <a:prstGeom prst="rect">
             <a:avLst/>
@@ -5733,7 +6508,7 @@
               </a:spcAft>
             </a:pPr>
             <a:r>
-              <a:rPr sz="3800" b="1" i="0">
+              <a:rPr sz="3600" b="1" i="0">
                 <a:solidFill>
                   <a:srgbClr val="F7F2E7"/>
                 </a:solidFill>
@@ -5752,7 +6527,7 @@
         </p:nvSpPr>
         <p:spPr>
           <a:xfrm>
-            <a:off x="822960" y="2468880"/>
+            <a:off x="822960" y="2331720"/>
             <a:ext cx="10515600" cy="1170432"/>
           </a:xfrm>
           <a:prstGeom prst="roundRect">
@@ -5798,7 +6573,7 @@
         </p:nvSpPr>
         <p:spPr>
           <a:xfrm>
-            <a:off x="1097280" y="2761488"/>
+            <a:off x="1097280" y="2624327"/>
             <a:ext cx="603504" cy="603504"/>
           </a:xfrm>
           <a:prstGeom prst="ellipse">
@@ -5842,7 +6617,7 @@
         </p:nvSpPr>
         <p:spPr>
           <a:xfrm>
-            <a:off x="1097280" y="2779776"/>
+            <a:off x="1097280" y="2642615"/>
             <a:ext cx="603504" cy="603504"/>
           </a:xfrm>
           <a:prstGeom prst="rect">
@@ -5870,7 +6645,7 @@
             <a:r>
               <a:rPr sz="2400" b="1" i="0">
                 <a:solidFill>
-                  <a:srgbClr val="0E0B16"/>
+                  <a:srgbClr val="0C0A14"/>
                 </a:solidFill>
                 <a:latin typeface="Georgia"/>
               </a:rPr>
@@ -5887,7 +6662,7 @@
         </p:nvSpPr>
         <p:spPr>
           <a:xfrm>
-            <a:off x="1965960" y="2615184"/>
+            <a:off x="1965960" y="2478024"/>
             <a:ext cx="2194560" cy="914400"/>
           </a:xfrm>
           <a:prstGeom prst="rect">
@@ -5932,7 +6707,7 @@
         </p:nvSpPr>
         <p:spPr>
           <a:xfrm>
-            <a:off x="4114800" y="2578608"/>
+            <a:off x="4114800" y="2441448"/>
             <a:ext cx="6949440" cy="960120"/>
           </a:xfrm>
           <a:prstGeom prst="rect">
@@ -5977,7 +6752,7 @@
         </p:nvSpPr>
         <p:spPr>
           <a:xfrm>
-            <a:off x="822960" y="3840480"/>
+            <a:off x="822960" y="3703320"/>
             <a:ext cx="10515600" cy="1170432"/>
           </a:xfrm>
           <a:prstGeom prst="roundRect">
@@ -6023,7 +6798,7 @@
         </p:nvSpPr>
         <p:spPr>
           <a:xfrm>
-            <a:off x="1097280" y="4133088"/>
+            <a:off x="1097280" y="3995928"/>
             <a:ext cx="603504" cy="603504"/>
           </a:xfrm>
           <a:prstGeom prst="ellipse">
@@ -6067,7 +6842,7 @@
         </p:nvSpPr>
         <p:spPr>
           <a:xfrm>
-            <a:off x="1097280" y="4151376"/>
+            <a:off x="1097280" y="4014215"/>
             <a:ext cx="603504" cy="603504"/>
           </a:xfrm>
           <a:prstGeom prst="rect">
@@ -6095,7 +6870,7 @@
             <a:r>
               <a:rPr sz="2400" b="1" i="0">
                 <a:solidFill>
-                  <a:srgbClr val="0E0B16"/>
+                  <a:srgbClr val="0C0A14"/>
                 </a:solidFill>
                 <a:latin typeface="Georgia"/>
               </a:rPr>
@@ -6112,7 +6887,7 @@
         </p:nvSpPr>
         <p:spPr>
           <a:xfrm>
-            <a:off x="1965960" y="3986784"/>
+            <a:off x="1965960" y="3849624"/>
             <a:ext cx="2194560" cy="914400"/>
           </a:xfrm>
           <a:prstGeom prst="rect">
@@ -6157,7 +6932,7 @@
         </p:nvSpPr>
         <p:spPr>
           <a:xfrm>
-            <a:off x="4114800" y="3950208"/>
+            <a:off x="4114800" y="3813048"/>
             <a:ext cx="6949440" cy="960120"/>
           </a:xfrm>
           <a:prstGeom prst="rect">
@@ -6189,7 +6964,7 @@
                 </a:solidFill>
                 <a:latin typeface="Segoe UI"/>
               </a:rPr>
-              <a:t>Akkaverse auto-generates a bilingual micro-lesson — a phrase to repeat, key vocabulary, and a meaning check for the next generation.</a:t>
+              <a:t>Akkaverse auto-generates a bilingual micro-lesson — a phrase to repeat, key vocabulary and a meaning check for the next generation.</a:t>
             </a:r>
           </a:p>
         </p:txBody>
@@ -6202,7 +6977,7 @@
         </p:nvSpPr>
         <p:spPr>
           <a:xfrm>
-            <a:off x="822960" y="5212080"/>
+            <a:off x="822960" y="5074920"/>
             <a:ext cx="10515600" cy="1170432"/>
           </a:xfrm>
           <a:prstGeom prst="roundRect">
@@ -6248,7 +7023,7 @@
         </p:nvSpPr>
         <p:spPr>
           <a:xfrm>
-            <a:off x="1097280" y="5504688"/>
+            <a:off x="1097280" y="5367528"/>
             <a:ext cx="603504" cy="603504"/>
           </a:xfrm>
           <a:prstGeom prst="ellipse">
@@ -6292,7 +7067,7 @@
         </p:nvSpPr>
         <p:spPr>
           <a:xfrm>
-            <a:off x="1097280" y="5522976"/>
+            <a:off x="1097280" y="5385816"/>
             <a:ext cx="603504" cy="603504"/>
           </a:xfrm>
           <a:prstGeom prst="rect">
@@ -6320,7 +7095,7 @@
             <a:r>
               <a:rPr sz="2400" b="1" i="0">
                 <a:solidFill>
-                  <a:srgbClr val="0E0B16"/>
+                  <a:srgbClr val="0C0A14"/>
                 </a:solidFill>
                 <a:latin typeface="Georgia"/>
               </a:rPr>
@@ -6337,7 +7112,7 @@
         </p:nvSpPr>
         <p:spPr>
           <a:xfrm>
-            <a:off x="1965960" y="5358384"/>
+            <a:off x="1965960" y="5221224"/>
             <a:ext cx="2194560" cy="914400"/>
           </a:xfrm>
           <a:prstGeom prst="rect">
@@ -6382,7 +7157,7 @@
         </p:nvSpPr>
         <p:spPr>
           <a:xfrm>
-            <a:off x="4114800" y="5321808"/>
+            <a:off x="4114800" y="5184648"/>
             <a:ext cx="6949440" cy="960120"/>
           </a:xfrm>
           <a:prstGeom prst="rect">
@@ -6415,6 +7190,185 @@
                 <a:latin typeface="Segoe UI"/>
               </a:rPr>
               <a:t>Explore the wider culture with a grounded AI guide, an interactive map, a cinematic timeline, festivals, stories and quizzes.</a:t>
+            </a:r>
+          </a:p>
+        </p:txBody>
+      </p:sp>
+      <p:sp>
+        <p:nvSpPr>
+          <p:cNvPr id="21" name="Rectangle 20"/>
+          <p:cNvSpPr/>
+          <p:nvPr/>
+        </p:nvSpPr>
+        <p:spPr>
+          <a:xfrm>
+            <a:off x="822960" y="6419088"/>
+            <a:ext cx="10543032" cy="12801"/>
+          </a:xfrm>
+          <a:prstGeom prst="rect">
+            <a:avLst/>
+          </a:prstGeom>
+          <a:solidFill>
+            <a:srgbClr val="1A142C"/>
+          </a:solidFill>
+          <a:ln>
+            <a:noFill/>
+          </a:ln>
+          <a:effectLst/>
+        </p:spPr>
+        <p:style>
+          <a:lnRef idx="1">
+            <a:schemeClr val="accent1"/>
+          </a:lnRef>
+          <a:fillRef idx="3">
+            <a:schemeClr val="accent1"/>
+          </a:fillRef>
+          <a:effectRef idx="2">
+            <a:schemeClr val="accent1"/>
+          </a:effectRef>
+          <a:fontRef idx="minor">
+            <a:schemeClr val="lt1"/>
+          </a:fontRef>
+        </p:style>
+        <p:txBody>
+          <a:bodyPr rtlCol="0" anchor="ctr"/>
+          <a:lstStyle/>
+          <a:p>
+            <a:pPr algn="ctr"/>
+          </a:p>
+        </p:txBody>
+      </p:sp>
+      <p:sp>
+        <p:nvSpPr>
+          <p:cNvPr id="22" name="TextBox 21"/>
+          <p:cNvSpPr txBox="1"/>
+          <p:nvPr/>
+        </p:nvSpPr>
+        <p:spPr>
+          <a:xfrm>
+            <a:off x="822960" y="6473952"/>
+            <a:ext cx="6400800" cy="320040"/>
+          </a:xfrm>
+          <a:prstGeom prst="rect">
+            <a:avLst/>
+          </a:prstGeom>
+          <a:noFill/>
+        </p:spPr>
+        <p:txBody>
+          <a:bodyPr wrap="square" anchor="t" lIns="0" rIns="0" tIns="0" bIns="0">
+            <a:spAutoFit/>
+          </a:bodyPr>
+          <a:lstStyle/>
+          <a:p>
+            <a:pPr algn="l">
+              <a:lnSpc>
+                <a:spcPct val="100000"/>
+              </a:lnSpc>
+              <a:spcBef>
+                <a:spcPts val="0"/>
+              </a:spcBef>
+              <a:spcAft>
+                <a:spcPts val="600"/>
+              </a:spcAft>
+            </a:pPr>
+            <a:r>
+              <a:rPr sz="1100" b="1" i="0">
+                <a:solidFill>
+                  <a:srgbClr val="B9B0C8"/>
+                </a:solidFill>
+                <a:latin typeface="Segoe UI"/>
+              </a:rPr>
+              <a:t>ಅಕ್ಕ  Akkaverse</a:t>
+            </a:r>
+          </a:p>
+        </p:txBody>
+      </p:sp>
+      <p:sp>
+        <p:nvSpPr>
+          <p:cNvPr id="23" name="TextBox 22"/>
+          <p:cNvSpPr txBox="1"/>
+          <p:nvPr/>
+        </p:nvSpPr>
+        <p:spPr>
+          <a:xfrm>
+            <a:off x="5486400" y="6473952"/>
+            <a:ext cx="3657600" cy="320040"/>
+          </a:xfrm>
+          <a:prstGeom prst="rect">
+            <a:avLst/>
+          </a:prstGeom>
+          <a:noFill/>
+        </p:spPr>
+        <p:txBody>
+          <a:bodyPr wrap="square" anchor="t" lIns="0" rIns="0" tIns="0" bIns="0">
+            <a:spAutoFit/>
+          </a:bodyPr>
+          <a:lstStyle/>
+          <a:p>
+            <a:pPr algn="ctr">
+              <a:lnSpc>
+                <a:spcPct val="100000"/>
+              </a:lnSpc>
+              <a:spcBef>
+                <a:spcPts val="0"/>
+              </a:spcBef>
+              <a:spcAft>
+                <a:spcPts val="600"/>
+              </a:spcAft>
+            </a:pPr>
+            <a:r>
+              <a:rPr sz="1100" b="0" i="0">
+                <a:solidFill>
+                  <a:srgbClr val="B9B0C8"/>
+                </a:solidFill>
+                <a:latin typeface="Segoe UI"/>
+              </a:rPr>
+              <a:t>Built by Mithun R</a:t>
+            </a:r>
+          </a:p>
+        </p:txBody>
+      </p:sp>
+      <p:sp>
+        <p:nvSpPr>
+          <p:cNvPr id="24" name="TextBox 23"/>
+          <p:cNvSpPr txBox="1"/>
+          <p:nvPr/>
+        </p:nvSpPr>
+        <p:spPr>
+          <a:xfrm>
+            <a:off x="9509760" y="6473952"/>
+            <a:ext cx="1856231" cy="320040"/>
+          </a:xfrm>
+          <a:prstGeom prst="rect">
+            <a:avLst/>
+          </a:prstGeom>
+          <a:noFill/>
+        </p:spPr>
+        <p:txBody>
+          <a:bodyPr wrap="square" anchor="t" lIns="0" rIns="0" tIns="0" bIns="0">
+            <a:spAutoFit/>
+          </a:bodyPr>
+          <a:lstStyle/>
+          <a:p>
+            <a:pPr algn="r">
+              <a:lnSpc>
+                <a:spcPct val="100000"/>
+              </a:lnSpc>
+              <a:spcBef>
+                <a:spcPts val="0"/>
+              </a:spcBef>
+              <a:spcAft>
+                <a:spcPts val="600"/>
+              </a:spcAft>
+            </a:pPr>
+            <a:r>
+              <a:rPr sz="1100" b="1" i="0">
+                <a:solidFill>
+                  <a:srgbClr val="FF9F1C"/>
+                </a:solidFill>
+                <a:latin typeface="Segoe UI"/>
+              </a:rPr>
+              <a:t>03 / 10</a:t>
             </a:r>
           </a:p>
         </p:txBody>
@@ -6452,7 +7406,7 @@
             <a:avLst/>
           </a:prstGeom>
           <a:solidFill>
-            <a:srgbClr val="0E0B16"/>
+            <a:srgbClr val="0C0A14"/>
           </a:solidFill>
           <a:ln>
             <a:noFill/>
@@ -6489,7 +7443,7 @@
         </p:nvSpPr>
         <p:spPr>
           <a:xfrm>
-            <a:off x="822960" y="786384"/>
+            <a:off x="822960" y="822960"/>
             <a:ext cx="82296" cy="310896"/>
           </a:xfrm>
           <a:prstGeom prst="rect">
@@ -6533,7 +7487,7 @@
         </p:nvSpPr>
         <p:spPr>
           <a:xfrm>
-            <a:off x="1024128" y="749808"/>
+            <a:off x="1024128" y="786384"/>
             <a:ext cx="8229600" cy="457200"/>
           </a:xfrm>
           <a:prstGeom prst="rect">
@@ -6578,7 +7532,7 @@
         </p:nvSpPr>
         <p:spPr>
           <a:xfrm>
-            <a:off x="822960" y="1234440"/>
+            <a:off x="822960" y="1188720"/>
             <a:ext cx="10515600" cy="914400"/>
           </a:xfrm>
           <a:prstGeom prst="rect">
@@ -6604,7 +7558,7 @@
               </a:spcAft>
             </a:pPr>
             <a:r>
-              <a:rPr sz="3800" b="1" i="0">
+              <a:rPr sz="3600" b="1" i="0">
                 <a:solidFill>
                   <a:srgbClr val="F7F2E7"/>
                 </a:solidFill>
@@ -6623,8 +7577,8 @@
         </p:nvSpPr>
         <p:spPr>
           <a:xfrm>
-            <a:off x="822960" y="2514600"/>
-            <a:ext cx="5166360" cy="1783080"/>
+            <a:off x="822960" y="2331720"/>
+            <a:ext cx="5166360" cy="1737360"/>
           </a:xfrm>
           <a:prstGeom prst="roundRect">
             <a:avLst>
@@ -6669,8 +7623,8 @@
         </p:nvSpPr>
         <p:spPr>
           <a:xfrm>
-            <a:off x="822960" y="2514600"/>
-            <a:ext cx="128016" cy="1783080"/>
+            <a:off x="822960" y="2331720"/>
+            <a:ext cx="128016" cy="1737360"/>
           </a:xfrm>
           <a:prstGeom prst="rect">
             <a:avLst/>
@@ -6713,7 +7667,7 @@
         </p:nvSpPr>
         <p:spPr>
           <a:xfrm>
-            <a:off x="1188720" y="2770632"/>
+            <a:off x="1188720" y="2587752"/>
             <a:ext cx="4572000" cy="548640"/>
           </a:xfrm>
           <a:prstGeom prst="rect">
@@ -6758,7 +7712,7 @@
         </p:nvSpPr>
         <p:spPr>
           <a:xfrm>
-            <a:off x="1188720" y="3410712"/>
+            <a:off x="1188720" y="3209544"/>
             <a:ext cx="4572000" cy="822960"/>
           </a:xfrm>
           <a:prstGeom prst="rect">
@@ -6803,8 +7757,8 @@
         </p:nvSpPr>
         <p:spPr>
           <a:xfrm>
-            <a:off x="6172200" y="2514600"/>
-            <a:ext cx="5166360" cy="1783080"/>
+            <a:off x="6172200" y="2331720"/>
+            <a:ext cx="5166360" cy="1737360"/>
           </a:xfrm>
           <a:prstGeom prst="roundRect">
             <a:avLst>
@@ -6849,8 +7803,8 @@
         </p:nvSpPr>
         <p:spPr>
           <a:xfrm>
-            <a:off x="6172200" y="2514600"/>
-            <a:ext cx="128016" cy="1783080"/>
+            <a:off x="6172200" y="2331720"/>
+            <a:ext cx="128016" cy="1737360"/>
           </a:xfrm>
           <a:prstGeom prst="rect">
             <a:avLst/>
@@ -6893,7 +7847,7 @@
         </p:nvSpPr>
         <p:spPr>
           <a:xfrm>
-            <a:off x="6537960" y="2770632"/>
+            <a:off x="6537960" y="2587752"/>
             <a:ext cx="4572000" cy="548640"/>
           </a:xfrm>
           <a:prstGeom prst="rect">
@@ -6938,7 +7892,7 @@
         </p:nvSpPr>
         <p:spPr>
           <a:xfrm>
-            <a:off x="6537960" y="3410712"/>
+            <a:off x="6537960" y="3209544"/>
             <a:ext cx="4572000" cy="822960"/>
           </a:xfrm>
           <a:prstGeom prst="rect">
@@ -6983,8 +7937,8 @@
         </p:nvSpPr>
         <p:spPr>
           <a:xfrm>
-            <a:off x="822960" y="4572000"/>
-            <a:ext cx="5166360" cy="1783080"/>
+            <a:off x="822960" y="4315968"/>
+            <a:ext cx="5166360" cy="1737360"/>
           </a:xfrm>
           <a:prstGeom prst="roundRect">
             <a:avLst>
@@ -7029,8 +7983,8 @@
         </p:nvSpPr>
         <p:spPr>
           <a:xfrm>
-            <a:off x="822960" y="4572000"/>
-            <a:ext cx="128016" cy="1783080"/>
+            <a:off x="822960" y="4315968"/>
+            <a:ext cx="128016" cy="1737360"/>
           </a:xfrm>
           <a:prstGeom prst="rect">
             <a:avLst/>
@@ -7073,7 +8027,7 @@
         </p:nvSpPr>
         <p:spPr>
           <a:xfrm>
-            <a:off x="1188720" y="4828032"/>
+            <a:off x="1188720" y="4572000"/>
             <a:ext cx="4572000" cy="548640"/>
           </a:xfrm>
           <a:prstGeom prst="rect">
@@ -7118,7 +8072,7 @@
         </p:nvSpPr>
         <p:spPr>
           <a:xfrm>
-            <a:off x="1188720" y="5468112"/>
+            <a:off x="1188720" y="5193792"/>
             <a:ext cx="4572000" cy="822960"/>
           </a:xfrm>
           <a:prstGeom prst="rect">
@@ -7163,8 +8117,8 @@
         </p:nvSpPr>
         <p:spPr>
           <a:xfrm>
-            <a:off x="6172200" y="4572000"/>
-            <a:ext cx="5166360" cy="1783080"/>
+            <a:off x="6172200" y="4315968"/>
+            <a:ext cx="5166360" cy="1737360"/>
           </a:xfrm>
           <a:prstGeom prst="roundRect">
             <a:avLst>
@@ -7209,8 +8163,8 @@
         </p:nvSpPr>
         <p:spPr>
           <a:xfrm>
-            <a:off x="6172200" y="4572000"/>
-            <a:ext cx="128016" cy="1783080"/>
+            <a:off x="6172200" y="4315968"/>
+            <a:ext cx="128016" cy="1737360"/>
           </a:xfrm>
           <a:prstGeom prst="rect">
             <a:avLst/>
@@ -7253,7 +8207,7 @@
         </p:nvSpPr>
         <p:spPr>
           <a:xfrm>
-            <a:off x="6537960" y="4828032"/>
+            <a:off x="6537960" y="4572000"/>
             <a:ext cx="4572000" cy="548640"/>
           </a:xfrm>
           <a:prstGeom prst="rect">
@@ -7298,7 +8252,7 @@
         </p:nvSpPr>
         <p:spPr>
           <a:xfrm>
-            <a:off x="6537960" y="5468112"/>
+            <a:off x="6537960" y="5193792"/>
             <a:ext cx="4572000" cy="822960"/>
           </a:xfrm>
           <a:prstGeom prst="rect">
@@ -7343,7 +8297,7 @@
         </p:nvSpPr>
         <p:spPr>
           <a:xfrm>
-            <a:off x="822960" y="6419088"/>
+            <a:off x="822960" y="6199632"/>
             <a:ext cx="10515600" cy="365760"/>
           </a:xfrm>
           <a:prstGeom prst="rect">
@@ -7376,6 +8330,185 @@
                 <a:latin typeface="Segoe UI"/>
               </a:rPr>
               <a:t>Fully bilingual  ·  no login  ·  works offline (PWA)</a:t>
+            </a:r>
+          </a:p>
+        </p:txBody>
+      </p:sp>
+      <p:sp>
+        <p:nvSpPr>
+          <p:cNvPr id="23" name="Rectangle 22"/>
+          <p:cNvSpPr/>
+          <p:nvPr/>
+        </p:nvSpPr>
+        <p:spPr>
+          <a:xfrm>
+            <a:off x="822960" y="6419088"/>
+            <a:ext cx="10543032" cy="12801"/>
+          </a:xfrm>
+          <a:prstGeom prst="rect">
+            <a:avLst/>
+          </a:prstGeom>
+          <a:solidFill>
+            <a:srgbClr val="1A142C"/>
+          </a:solidFill>
+          <a:ln>
+            <a:noFill/>
+          </a:ln>
+          <a:effectLst/>
+        </p:spPr>
+        <p:style>
+          <a:lnRef idx="1">
+            <a:schemeClr val="accent1"/>
+          </a:lnRef>
+          <a:fillRef idx="3">
+            <a:schemeClr val="accent1"/>
+          </a:fillRef>
+          <a:effectRef idx="2">
+            <a:schemeClr val="accent1"/>
+          </a:effectRef>
+          <a:fontRef idx="minor">
+            <a:schemeClr val="lt1"/>
+          </a:fontRef>
+        </p:style>
+        <p:txBody>
+          <a:bodyPr rtlCol="0" anchor="ctr"/>
+          <a:lstStyle/>
+          <a:p>
+            <a:pPr algn="ctr"/>
+          </a:p>
+        </p:txBody>
+      </p:sp>
+      <p:sp>
+        <p:nvSpPr>
+          <p:cNvPr id="24" name="TextBox 23"/>
+          <p:cNvSpPr txBox="1"/>
+          <p:nvPr/>
+        </p:nvSpPr>
+        <p:spPr>
+          <a:xfrm>
+            <a:off x="822960" y="6473952"/>
+            <a:ext cx="6400800" cy="320040"/>
+          </a:xfrm>
+          <a:prstGeom prst="rect">
+            <a:avLst/>
+          </a:prstGeom>
+          <a:noFill/>
+        </p:spPr>
+        <p:txBody>
+          <a:bodyPr wrap="square" anchor="t" lIns="0" rIns="0" tIns="0" bIns="0">
+            <a:spAutoFit/>
+          </a:bodyPr>
+          <a:lstStyle/>
+          <a:p>
+            <a:pPr algn="l">
+              <a:lnSpc>
+                <a:spcPct val="100000"/>
+              </a:lnSpc>
+              <a:spcBef>
+                <a:spcPts val="0"/>
+              </a:spcBef>
+              <a:spcAft>
+                <a:spcPts val="600"/>
+              </a:spcAft>
+            </a:pPr>
+            <a:r>
+              <a:rPr sz="1100" b="1" i="0">
+                <a:solidFill>
+                  <a:srgbClr val="B9B0C8"/>
+                </a:solidFill>
+                <a:latin typeface="Segoe UI"/>
+              </a:rPr>
+              <a:t>ಅಕ್ಕ  Akkaverse</a:t>
+            </a:r>
+          </a:p>
+        </p:txBody>
+      </p:sp>
+      <p:sp>
+        <p:nvSpPr>
+          <p:cNvPr id="25" name="TextBox 24"/>
+          <p:cNvSpPr txBox="1"/>
+          <p:nvPr/>
+        </p:nvSpPr>
+        <p:spPr>
+          <a:xfrm>
+            <a:off x="5486400" y="6473952"/>
+            <a:ext cx="3657600" cy="320040"/>
+          </a:xfrm>
+          <a:prstGeom prst="rect">
+            <a:avLst/>
+          </a:prstGeom>
+          <a:noFill/>
+        </p:spPr>
+        <p:txBody>
+          <a:bodyPr wrap="square" anchor="t" lIns="0" rIns="0" tIns="0" bIns="0">
+            <a:spAutoFit/>
+          </a:bodyPr>
+          <a:lstStyle/>
+          <a:p>
+            <a:pPr algn="ctr">
+              <a:lnSpc>
+                <a:spcPct val="100000"/>
+              </a:lnSpc>
+              <a:spcBef>
+                <a:spcPts val="0"/>
+              </a:spcBef>
+              <a:spcAft>
+                <a:spcPts val="600"/>
+              </a:spcAft>
+            </a:pPr>
+            <a:r>
+              <a:rPr sz="1100" b="0" i="0">
+                <a:solidFill>
+                  <a:srgbClr val="B9B0C8"/>
+                </a:solidFill>
+                <a:latin typeface="Segoe UI"/>
+              </a:rPr>
+              <a:t>Built by Mithun R</a:t>
+            </a:r>
+          </a:p>
+        </p:txBody>
+      </p:sp>
+      <p:sp>
+        <p:nvSpPr>
+          <p:cNvPr id="26" name="TextBox 25"/>
+          <p:cNvSpPr txBox="1"/>
+          <p:nvPr/>
+        </p:nvSpPr>
+        <p:spPr>
+          <a:xfrm>
+            <a:off x="9509760" y="6473952"/>
+            <a:ext cx="1856231" cy="320040"/>
+          </a:xfrm>
+          <a:prstGeom prst="rect">
+            <a:avLst/>
+          </a:prstGeom>
+          <a:noFill/>
+        </p:spPr>
+        <p:txBody>
+          <a:bodyPr wrap="square" anchor="t" lIns="0" rIns="0" tIns="0" bIns="0">
+            <a:spAutoFit/>
+          </a:bodyPr>
+          <a:lstStyle/>
+          <a:p>
+            <a:pPr algn="r">
+              <a:lnSpc>
+                <a:spcPct val="100000"/>
+              </a:lnSpc>
+              <a:spcBef>
+                <a:spcPts val="0"/>
+              </a:spcBef>
+              <a:spcAft>
+                <a:spcPts val="600"/>
+              </a:spcAft>
+            </a:pPr>
+            <a:r>
+              <a:rPr sz="1100" b="1" i="0">
+                <a:solidFill>
+                  <a:srgbClr val="FF9F1C"/>
+                </a:solidFill>
+                <a:latin typeface="Segoe UI"/>
+              </a:rPr>
+              <a:t>04 / 10</a:t>
             </a:r>
           </a:p>
         </p:txBody>
@@ -7413,7 +8546,7 @@
             <a:avLst/>
           </a:prstGeom>
           <a:solidFill>
-            <a:srgbClr val="0E0B16"/>
+            <a:srgbClr val="0C0A14"/>
           </a:solidFill>
           <a:ln>
             <a:noFill/>
@@ -7450,7 +8583,7 @@
         </p:nvSpPr>
         <p:spPr>
           <a:xfrm>
-            <a:off x="822960" y="786384"/>
+            <a:off x="822960" y="822960"/>
             <a:ext cx="82296" cy="310896"/>
           </a:xfrm>
           <a:prstGeom prst="rect">
@@ -7494,7 +8627,7 @@
         </p:nvSpPr>
         <p:spPr>
           <a:xfrm>
-            <a:off x="1024128" y="749808"/>
+            <a:off x="1024128" y="786384"/>
             <a:ext cx="8229600" cy="457200"/>
           </a:xfrm>
           <a:prstGeom prst="rect">
@@ -7539,7 +8672,7 @@
         </p:nvSpPr>
         <p:spPr>
           <a:xfrm>
-            <a:off x="822960" y="1234440"/>
+            <a:off x="822960" y="1188720"/>
             <a:ext cx="10515600" cy="914400"/>
           </a:xfrm>
           <a:prstGeom prst="rect">
@@ -7565,7 +8698,7 @@
               </a:spcAft>
             </a:pPr>
             <a:r>
-              <a:rPr sz="3800" b="1" i="0">
+              <a:rPr sz="3600" b="1" i="0">
                 <a:solidFill>
                   <a:srgbClr val="F7F2E7"/>
                 </a:solidFill>
@@ -7584,7 +8717,7 @@
         </p:nvSpPr>
         <p:spPr>
           <a:xfrm>
-            <a:off x="822960" y="2651760"/>
+            <a:off x="822960" y="2514600"/>
             <a:ext cx="1965960" cy="1600200"/>
           </a:xfrm>
           <a:prstGeom prst="roundRect">
@@ -7630,7 +8763,7 @@
         </p:nvSpPr>
         <p:spPr>
           <a:xfrm>
-            <a:off x="822960" y="2651760"/>
+            <a:off x="822960" y="2514600"/>
             <a:ext cx="1965960" cy="109728"/>
           </a:xfrm>
           <a:prstGeom prst="rect">
@@ -7674,7 +8807,7 @@
         </p:nvSpPr>
         <p:spPr>
           <a:xfrm>
-            <a:off x="1005840" y="2889504"/>
+            <a:off x="1005840" y="2743200"/>
             <a:ext cx="1645920" cy="548640"/>
           </a:xfrm>
           <a:prstGeom prst="rect">
@@ -7719,7 +8852,7 @@
         </p:nvSpPr>
         <p:spPr>
           <a:xfrm>
-            <a:off x="1005840" y="3429000"/>
+            <a:off x="1005840" y="3291840"/>
             <a:ext cx="1645920" cy="822960"/>
           </a:xfrm>
           <a:prstGeom prst="rect">
@@ -7764,7 +8897,7 @@
         </p:nvSpPr>
         <p:spPr>
           <a:xfrm>
-            <a:off x="2788920" y="3063240"/>
+            <a:off x="2788920" y="2926080"/>
             <a:ext cx="365760" cy="731520"/>
           </a:xfrm>
           <a:prstGeom prst="rect">
@@ -7809,7 +8942,7 @@
         </p:nvSpPr>
         <p:spPr>
           <a:xfrm>
-            <a:off x="3035808" y="2651760"/>
+            <a:off x="3035808" y="2514600"/>
             <a:ext cx="1965960" cy="1600200"/>
           </a:xfrm>
           <a:prstGeom prst="roundRect">
@@ -7855,7 +8988,7 @@
         </p:nvSpPr>
         <p:spPr>
           <a:xfrm>
-            <a:off x="3035808" y="2651760"/>
+            <a:off x="3035808" y="2514600"/>
             <a:ext cx="1965960" cy="109728"/>
           </a:xfrm>
           <a:prstGeom prst="rect">
@@ -7899,7 +9032,7 @@
         </p:nvSpPr>
         <p:spPr>
           <a:xfrm>
-            <a:off x="3218688" y="2889504"/>
+            <a:off x="3218688" y="2743200"/>
             <a:ext cx="1645920" cy="548640"/>
           </a:xfrm>
           <a:prstGeom prst="rect">
@@ -7944,7 +9077,7 @@
         </p:nvSpPr>
         <p:spPr>
           <a:xfrm>
-            <a:off x="3218688" y="3429000"/>
+            <a:off x="3218688" y="3291840"/>
             <a:ext cx="1645920" cy="822960"/>
           </a:xfrm>
           <a:prstGeom prst="rect">
@@ -7990,7 +9123,7 @@
         </p:nvSpPr>
         <p:spPr>
           <a:xfrm>
-            <a:off x="5001768" y="3063240"/>
+            <a:off x="5001768" y="2926080"/>
             <a:ext cx="365760" cy="731520"/>
           </a:xfrm>
           <a:prstGeom prst="rect">
@@ -8035,7 +9168,7 @@
         </p:nvSpPr>
         <p:spPr>
           <a:xfrm>
-            <a:off x="5248656" y="2651760"/>
+            <a:off x="5248656" y="2514600"/>
             <a:ext cx="1965960" cy="1600200"/>
           </a:xfrm>
           <a:prstGeom prst="roundRect">
@@ -8081,7 +9214,7 @@
         </p:nvSpPr>
         <p:spPr>
           <a:xfrm>
-            <a:off x="5248656" y="2651760"/>
+            <a:off x="5248656" y="2514600"/>
             <a:ext cx="1965960" cy="109728"/>
           </a:xfrm>
           <a:prstGeom prst="rect">
@@ -8125,7 +9258,7 @@
         </p:nvSpPr>
         <p:spPr>
           <a:xfrm>
-            <a:off x="5431536" y="2889504"/>
+            <a:off x="5431536" y="2743200"/>
             <a:ext cx="1645920" cy="548640"/>
           </a:xfrm>
           <a:prstGeom prst="rect">
@@ -8170,7 +9303,7 @@
         </p:nvSpPr>
         <p:spPr>
           <a:xfrm>
-            <a:off x="5431536" y="3429000"/>
+            <a:off x="5431536" y="3291840"/>
             <a:ext cx="1645920" cy="822960"/>
           </a:xfrm>
           <a:prstGeom prst="rect">
@@ -8216,7 +9349,7 @@
         </p:nvSpPr>
         <p:spPr>
           <a:xfrm>
-            <a:off x="7214616" y="3063240"/>
+            <a:off x="7214616" y="2926080"/>
             <a:ext cx="365760" cy="731520"/>
           </a:xfrm>
           <a:prstGeom prst="rect">
@@ -8261,7 +9394,7 @@
         </p:nvSpPr>
         <p:spPr>
           <a:xfrm>
-            <a:off x="7461504" y="2651760"/>
+            <a:off x="7461504" y="2514600"/>
             <a:ext cx="1965960" cy="1600200"/>
           </a:xfrm>
           <a:prstGeom prst="roundRect">
@@ -8307,7 +9440,7 @@
         </p:nvSpPr>
         <p:spPr>
           <a:xfrm>
-            <a:off x="7461504" y="2651760"/>
+            <a:off x="7461504" y="2514600"/>
             <a:ext cx="1965960" cy="109728"/>
           </a:xfrm>
           <a:prstGeom prst="rect">
@@ -8351,7 +9484,7 @@
         </p:nvSpPr>
         <p:spPr>
           <a:xfrm>
-            <a:off x="7644383" y="2889504"/>
+            <a:off x="7644383" y="2743200"/>
             <a:ext cx="1645920" cy="548640"/>
           </a:xfrm>
           <a:prstGeom prst="rect">
@@ -8396,7 +9529,7 @@
         </p:nvSpPr>
         <p:spPr>
           <a:xfrm>
-            <a:off x="7644383" y="3429000"/>
+            <a:off x="7644383" y="3291840"/>
             <a:ext cx="1645920" cy="822960"/>
           </a:xfrm>
           <a:prstGeom prst="rect">
@@ -8442,7 +9575,7 @@
         </p:nvSpPr>
         <p:spPr>
           <a:xfrm>
-            <a:off x="9427464" y="3063240"/>
+            <a:off x="9427464" y="2926080"/>
             <a:ext cx="365760" cy="731520"/>
           </a:xfrm>
           <a:prstGeom prst="rect">
@@ -8487,7 +9620,7 @@
         </p:nvSpPr>
         <p:spPr>
           <a:xfrm>
-            <a:off x="9674352" y="2651760"/>
+            <a:off x="9674352" y="2514600"/>
             <a:ext cx="1965960" cy="1600200"/>
           </a:xfrm>
           <a:prstGeom prst="roundRect">
@@ -8533,7 +9666,7 @@
         </p:nvSpPr>
         <p:spPr>
           <a:xfrm>
-            <a:off x="9674352" y="2651760"/>
+            <a:off x="9674352" y="2514600"/>
             <a:ext cx="1965960" cy="109728"/>
           </a:xfrm>
           <a:prstGeom prst="rect">
@@ -8577,7 +9710,7 @@
         </p:nvSpPr>
         <p:spPr>
           <a:xfrm>
-            <a:off x="9857232" y="2889504"/>
+            <a:off x="9857232" y="2743200"/>
             <a:ext cx="1645920" cy="548640"/>
           </a:xfrm>
           <a:prstGeom prst="rect">
@@ -8622,7 +9755,7 @@
         </p:nvSpPr>
         <p:spPr>
           <a:xfrm>
-            <a:off x="9857232" y="3429000"/>
+            <a:off x="9857232" y="3291840"/>
             <a:ext cx="1645920" cy="822960"/>
           </a:xfrm>
           <a:prstGeom prst="rect">
@@ -8668,7 +9801,7 @@
         </p:nvSpPr>
         <p:spPr>
           <a:xfrm>
-            <a:off x="822960" y="4663440"/>
+            <a:off x="822960" y="4526280"/>
             <a:ext cx="10515600" cy="1554480"/>
           </a:xfrm>
           <a:prstGeom prst="roundRect">
@@ -8714,7 +9847,7 @@
         </p:nvSpPr>
         <p:spPr>
           <a:xfrm>
-            <a:off x="1143000" y="4892040"/>
+            <a:off x="1143000" y="4709160"/>
             <a:ext cx="10058400" cy="1188720"/>
           </a:xfrm>
           <a:prstGeom prst="rect">
@@ -8747,6 +9880,185 @@
                 <a:latin typeface="Segoe UI"/>
               </a:rPr>
               <a:t>Server-only API key — never shipped to the browser. Local-first storage: family data in localStorage, original audio in IndexedDB. Nothing is uploaded. If the key or network is missing, curated fallbacks still answer.</a:t>
+            </a:r>
+          </a:p>
+        </p:txBody>
+      </p:sp>
+      <p:sp>
+        <p:nvSpPr>
+          <p:cNvPr id="32" name="Rectangle 31"/>
+          <p:cNvSpPr/>
+          <p:nvPr/>
+        </p:nvSpPr>
+        <p:spPr>
+          <a:xfrm>
+            <a:off x="822960" y="6419088"/>
+            <a:ext cx="10543032" cy="12801"/>
+          </a:xfrm>
+          <a:prstGeom prst="rect">
+            <a:avLst/>
+          </a:prstGeom>
+          <a:solidFill>
+            <a:srgbClr val="1A142C"/>
+          </a:solidFill>
+          <a:ln>
+            <a:noFill/>
+          </a:ln>
+          <a:effectLst/>
+        </p:spPr>
+        <p:style>
+          <a:lnRef idx="1">
+            <a:schemeClr val="accent1"/>
+          </a:lnRef>
+          <a:fillRef idx="3">
+            <a:schemeClr val="accent1"/>
+          </a:fillRef>
+          <a:effectRef idx="2">
+            <a:schemeClr val="accent1"/>
+          </a:effectRef>
+          <a:fontRef idx="minor">
+            <a:schemeClr val="lt1"/>
+          </a:fontRef>
+        </p:style>
+        <p:txBody>
+          <a:bodyPr rtlCol="0" anchor="ctr"/>
+          <a:lstStyle/>
+          <a:p>
+            <a:pPr algn="ctr"/>
+          </a:p>
+        </p:txBody>
+      </p:sp>
+      <p:sp>
+        <p:nvSpPr>
+          <p:cNvPr id="33" name="TextBox 32"/>
+          <p:cNvSpPr txBox="1"/>
+          <p:nvPr/>
+        </p:nvSpPr>
+        <p:spPr>
+          <a:xfrm>
+            <a:off x="822960" y="6473952"/>
+            <a:ext cx="6400800" cy="320040"/>
+          </a:xfrm>
+          <a:prstGeom prst="rect">
+            <a:avLst/>
+          </a:prstGeom>
+          <a:noFill/>
+        </p:spPr>
+        <p:txBody>
+          <a:bodyPr wrap="square" anchor="t" lIns="0" rIns="0" tIns="0" bIns="0">
+            <a:spAutoFit/>
+          </a:bodyPr>
+          <a:lstStyle/>
+          <a:p>
+            <a:pPr algn="l">
+              <a:lnSpc>
+                <a:spcPct val="100000"/>
+              </a:lnSpc>
+              <a:spcBef>
+                <a:spcPts val="0"/>
+              </a:spcBef>
+              <a:spcAft>
+                <a:spcPts val="600"/>
+              </a:spcAft>
+            </a:pPr>
+            <a:r>
+              <a:rPr sz="1100" b="1" i="0">
+                <a:solidFill>
+                  <a:srgbClr val="B9B0C8"/>
+                </a:solidFill>
+                <a:latin typeface="Segoe UI"/>
+              </a:rPr>
+              <a:t>ಅಕ್ಕ  Akkaverse</a:t>
+            </a:r>
+          </a:p>
+        </p:txBody>
+      </p:sp>
+      <p:sp>
+        <p:nvSpPr>
+          <p:cNvPr id="34" name="TextBox 33"/>
+          <p:cNvSpPr txBox="1"/>
+          <p:nvPr/>
+        </p:nvSpPr>
+        <p:spPr>
+          <a:xfrm>
+            <a:off x="5486400" y="6473952"/>
+            <a:ext cx="3657600" cy="320040"/>
+          </a:xfrm>
+          <a:prstGeom prst="rect">
+            <a:avLst/>
+          </a:prstGeom>
+          <a:noFill/>
+        </p:spPr>
+        <p:txBody>
+          <a:bodyPr wrap="square" anchor="t" lIns="0" rIns="0" tIns="0" bIns="0">
+            <a:spAutoFit/>
+          </a:bodyPr>
+          <a:lstStyle/>
+          <a:p>
+            <a:pPr algn="ctr">
+              <a:lnSpc>
+                <a:spcPct val="100000"/>
+              </a:lnSpc>
+              <a:spcBef>
+                <a:spcPts val="0"/>
+              </a:spcBef>
+              <a:spcAft>
+                <a:spcPts val="600"/>
+              </a:spcAft>
+            </a:pPr>
+            <a:r>
+              <a:rPr sz="1100" b="0" i="0">
+                <a:solidFill>
+                  <a:srgbClr val="B9B0C8"/>
+                </a:solidFill>
+                <a:latin typeface="Segoe UI"/>
+              </a:rPr>
+              <a:t>Built by Mithun R</a:t>
+            </a:r>
+          </a:p>
+        </p:txBody>
+      </p:sp>
+      <p:sp>
+        <p:nvSpPr>
+          <p:cNvPr id="35" name="TextBox 34"/>
+          <p:cNvSpPr txBox="1"/>
+          <p:nvPr/>
+        </p:nvSpPr>
+        <p:spPr>
+          <a:xfrm>
+            <a:off x="9509760" y="6473952"/>
+            <a:ext cx="1856231" cy="320040"/>
+          </a:xfrm>
+          <a:prstGeom prst="rect">
+            <a:avLst/>
+          </a:prstGeom>
+          <a:noFill/>
+        </p:spPr>
+        <p:txBody>
+          <a:bodyPr wrap="square" anchor="t" lIns="0" rIns="0" tIns="0" bIns="0">
+            <a:spAutoFit/>
+          </a:bodyPr>
+          <a:lstStyle/>
+          <a:p>
+            <a:pPr algn="r">
+              <a:lnSpc>
+                <a:spcPct val="100000"/>
+              </a:lnSpc>
+              <a:spcBef>
+                <a:spcPts val="0"/>
+              </a:spcBef>
+              <a:spcAft>
+                <a:spcPts val="600"/>
+              </a:spcAft>
+            </a:pPr>
+            <a:r>
+              <a:rPr sz="1100" b="1" i="0">
+                <a:solidFill>
+                  <a:srgbClr val="FF9F1C"/>
+                </a:solidFill>
+                <a:latin typeface="Segoe UI"/>
+              </a:rPr>
+              <a:t>05 / 10</a:t>
             </a:r>
           </a:p>
         </p:txBody>
@@ -8784,7 +10096,7 @@
             <a:avLst/>
           </a:prstGeom>
           <a:solidFill>
-            <a:srgbClr val="0E0B16"/>
+            <a:srgbClr val="0C0A14"/>
           </a:solidFill>
           <a:ln>
             <a:noFill/>
@@ -8821,7 +10133,7 @@
         </p:nvSpPr>
         <p:spPr>
           <a:xfrm>
-            <a:off x="822960" y="786384"/>
+            <a:off x="822960" y="822960"/>
             <a:ext cx="82296" cy="310896"/>
           </a:xfrm>
           <a:prstGeom prst="rect">
@@ -8865,7 +10177,7 @@
         </p:nvSpPr>
         <p:spPr>
           <a:xfrm>
-            <a:off x="1024128" y="749808"/>
+            <a:off x="1024128" y="786384"/>
             <a:ext cx="8229600" cy="457200"/>
           </a:xfrm>
           <a:prstGeom prst="rect">
@@ -8910,7 +10222,7 @@
         </p:nvSpPr>
         <p:spPr>
           <a:xfrm>
-            <a:off x="822960" y="1234440"/>
+            <a:off x="822960" y="1188720"/>
             <a:ext cx="10515600" cy="914400"/>
           </a:xfrm>
           <a:prstGeom prst="rect">
@@ -8936,7 +10248,7 @@
               </a:spcAft>
             </a:pPr>
             <a:r>
-              <a:rPr sz="3800" b="1" i="0">
+              <a:rPr sz="3600" b="1" i="0">
                 <a:solidFill>
                   <a:srgbClr val="F7F2E7"/>
                 </a:solidFill>
@@ -8955,7 +10267,7 @@
         </p:nvSpPr>
         <p:spPr>
           <a:xfrm>
-            <a:off x="868680" y="2514600"/>
+            <a:off x="868680" y="2377440"/>
             <a:ext cx="2377440" cy="457200"/>
           </a:xfrm>
           <a:prstGeom prst="rect">
@@ -9000,7 +10312,7 @@
         </p:nvSpPr>
         <p:spPr>
           <a:xfrm>
-            <a:off x="3383280" y="2514600"/>
+            <a:off x="3383280" y="2377440"/>
             <a:ext cx="7863840" cy="457200"/>
           </a:xfrm>
           <a:prstGeom prst="rect">
@@ -9045,7 +10357,7 @@
         </p:nvSpPr>
         <p:spPr>
           <a:xfrm>
-            <a:off x="868680" y="2990088"/>
+            <a:off x="868680" y="2852928"/>
             <a:ext cx="10424160" cy="10972"/>
           </a:xfrm>
           <a:prstGeom prst="rect">
@@ -9089,7 +10401,7 @@
         </p:nvSpPr>
         <p:spPr>
           <a:xfrm>
-            <a:off x="868680" y="3172968"/>
+            <a:off x="868680" y="3035808"/>
             <a:ext cx="2377440" cy="457200"/>
           </a:xfrm>
           <a:prstGeom prst="rect">
@@ -9134,7 +10446,7 @@
         </p:nvSpPr>
         <p:spPr>
           <a:xfrm>
-            <a:off x="3383280" y="3172968"/>
+            <a:off x="3383280" y="3035808"/>
             <a:ext cx="7863840" cy="457200"/>
           </a:xfrm>
           <a:prstGeom prst="rect">
@@ -9179,7 +10491,7 @@
         </p:nvSpPr>
         <p:spPr>
           <a:xfrm>
-            <a:off x="868680" y="3648456"/>
+            <a:off x="868680" y="3511296"/>
             <a:ext cx="10424160" cy="10972"/>
           </a:xfrm>
           <a:prstGeom prst="rect">
@@ -9223,7 +10535,7 @@
         </p:nvSpPr>
         <p:spPr>
           <a:xfrm>
-            <a:off x="868680" y="3831335"/>
+            <a:off x="868680" y="3694176"/>
             <a:ext cx="2377440" cy="457200"/>
           </a:xfrm>
           <a:prstGeom prst="rect">
@@ -9268,7 +10580,7 @@
         </p:nvSpPr>
         <p:spPr>
           <a:xfrm>
-            <a:off x="3383280" y="3831335"/>
+            <a:off x="3383280" y="3694176"/>
             <a:ext cx="7863840" cy="457200"/>
           </a:xfrm>
           <a:prstGeom prst="rect">
@@ -9313,7 +10625,7 @@
         </p:nvSpPr>
         <p:spPr>
           <a:xfrm>
-            <a:off x="868680" y="4306823"/>
+            <a:off x="868680" y="4169664"/>
             <a:ext cx="10424160" cy="10972"/>
           </a:xfrm>
           <a:prstGeom prst="rect">
@@ -9357,7 +10669,7 @@
         </p:nvSpPr>
         <p:spPr>
           <a:xfrm>
-            <a:off x="868680" y="4489703"/>
+            <a:off x="868680" y="4352544"/>
             <a:ext cx="2377440" cy="457200"/>
           </a:xfrm>
           <a:prstGeom prst="rect">
@@ -9402,7 +10714,7 @@
         </p:nvSpPr>
         <p:spPr>
           <a:xfrm>
-            <a:off x="3383280" y="4489703"/>
+            <a:off x="3383280" y="4352544"/>
             <a:ext cx="7863840" cy="457200"/>
           </a:xfrm>
           <a:prstGeom prst="rect">
@@ -9447,7 +10759,7 @@
         </p:nvSpPr>
         <p:spPr>
           <a:xfrm>
-            <a:off x="868680" y="4965192"/>
+            <a:off x="868680" y="4828031"/>
             <a:ext cx="10424160" cy="10972"/>
           </a:xfrm>
           <a:prstGeom prst="rect">
@@ -9491,7 +10803,7 @@
         </p:nvSpPr>
         <p:spPr>
           <a:xfrm>
-            <a:off x="868680" y="5148071"/>
+            <a:off x="868680" y="5010912"/>
             <a:ext cx="2377440" cy="457200"/>
           </a:xfrm>
           <a:prstGeom prst="rect">
@@ -9536,7 +10848,7 @@
         </p:nvSpPr>
         <p:spPr>
           <a:xfrm>
-            <a:off x="3383280" y="5148071"/>
+            <a:off x="3383280" y="5010912"/>
             <a:ext cx="7863840" cy="457200"/>
           </a:xfrm>
           <a:prstGeom prst="rect">
@@ -9581,7 +10893,7 @@
         </p:nvSpPr>
         <p:spPr>
           <a:xfrm>
-            <a:off x="868680" y="5623559"/>
+            <a:off x="868680" y="5486400"/>
             <a:ext cx="10424160" cy="10972"/>
           </a:xfrm>
           <a:prstGeom prst="rect">
@@ -9625,7 +10937,7 @@
         </p:nvSpPr>
         <p:spPr>
           <a:xfrm>
-            <a:off x="868680" y="5806439"/>
+            <a:off x="868680" y="5669279"/>
             <a:ext cx="2377440" cy="457200"/>
           </a:xfrm>
           <a:prstGeom prst="rect">
@@ -9670,7 +10982,7 @@
         </p:nvSpPr>
         <p:spPr>
           <a:xfrm>
-            <a:off x="3383280" y="5806439"/>
+            <a:off x="3383280" y="5669279"/>
             <a:ext cx="7863840" cy="457200"/>
           </a:xfrm>
           <a:prstGeom prst="rect">
@@ -9715,7 +11027,7 @@
         </p:nvSpPr>
         <p:spPr>
           <a:xfrm>
-            <a:off x="868680" y="6281927"/>
+            <a:off x="868680" y="6144767"/>
             <a:ext cx="10424160" cy="10972"/>
           </a:xfrm>
           <a:prstGeom prst="rect">
@@ -9748,6 +11060,185 @@
           <a:lstStyle/>
           <a:p>
             <a:pPr algn="ctr"/>
+          </a:p>
+        </p:txBody>
+      </p:sp>
+      <p:sp>
+        <p:nvSpPr>
+          <p:cNvPr id="24" name="Rectangle 23"/>
+          <p:cNvSpPr/>
+          <p:nvPr/>
+        </p:nvSpPr>
+        <p:spPr>
+          <a:xfrm>
+            <a:off x="822960" y="6419088"/>
+            <a:ext cx="10543032" cy="12801"/>
+          </a:xfrm>
+          <a:prstGeom prst="rect">
+            <a:avLst/>
+          </a:prstGeom>
+          <a:solidFill>
+            <a:srgbClr val="1A142C"/>
+          </a:solidFill>
+          <a:ln>
+            <a:noFill/>
+          </a:ln>
+          <a:effectLst/>
+        </p:spPr>
+        <p:style>
+          <a:lnRef idx="1">
+            <a:schemeClr val="accent1"/>
+          </a:lnRef>
+          <a:fillRef idx="3">
+            <a:schemeClr val="accent1"/>
+          </a:fillRef>
+          <a:effectRef idx="2">
+            <a:schemeClr val="accent1"/>
+          </a:effectRef>
+          <a:fontRef idx="minor">
+            <a:schemeClr val="lt1"/>
+          </a:fontRef>
+        </p:style>
+        <p:txBody>
+          <a:bodyPr rtlCol="0" anchor="ctr"/>
+          <a:lstStyle/>
+          <a:p>
+            <a:pPr algn="ctr"/>
+          </a:p>
+        </p:txBody>
+      </p:sp>
+      <p:sp>
+        <p:nvSpPr>
+          <p:cNvPr id="25" name="TextBox 24"/>
+          <p:cNvSpPr txBox="1"/>
+          <p:nvPr/>
+        </p:nvSpPr>
+        <p:spPr>
+          <a:xfrm>
+            <a:off x="822960" y="6473952"/>
+            <a:ext cx="6400800" cy="320040"/>
+          </a:xfrm>
+          <a:prstGeom prst="rect">
+            <a:avLst/>
+          </a:prstGeom>
+          <a:noFill/>
+        </p:spPr>
+        <p:txBody>
+          <a:bodyPr wrap="square" anchor="t" lIns="0" rIns="0" tIns="0" bIns="0">
+            <a:spAutoFit/>
+          </a:bodyPr>
+          <a:lstStyle/>
+          <a:p>
+            <a:pPr algn="l">
+              <a:lnSpc>
+                <a:spcPct val="100000"/>
+              </a:lnSpc>
+              <a:spcBef>
+                <a:spcPts val="0"/>
+              </a:spcBef>
+              <a:spcAft>
+                <a:spcPts val="600"/>
+              </a:spcAft>
+            </a:pPr>
+            <a:r>
+              <a:rPr sz="1100" b="1" i="0">
+                <a:solidFill>
+                  <a:srgbClr val="B9B0C8"/>
+                </a:solidFill>
+                <a:latin typeface="Segoe UI"/>
+              </a:rPr>
+              <a:t>ಅಕ್ಕ  Akkaverse</a:t>
+            </a:r>
+          </a:p>
+        </p:txBody>
+      </p:sp>
+      <p:sp>
+        <p:nvSpPr>
+          <p:cNvPr id="26" name="TextBox 25"/>
+          <p:cNvSpPr txBox="1"/>
+          <p:nvPr/>
+        </p:nvSpPr>
+        <p:spPr>
+          <a:xfrm>
+            <a:off x="5486400" y="6473952"/>
+            <a:ext cx="3657600" cy="320040"/>
+          </a:xfrm>
+          <a:prstGeom prst="rect">
+            <a:avLst/>
+          </a:prstGeom>
+          <a:noFill/>
+        </p:spPr>
+        <p:txBody>
+          <a:bodyPr wrap="square" anchor="t" lIns="0" rIns="0" tIns="0" bIns="0">
+            <a:spAutoFit/>
+          </a:bodyPr>
+          <a:lstStyle/>
+          <a:p>
+            <a:pPr algn="ctr">
+              <a:lnSpc>
+                <a:spcPct val="100000"/>
+              </a:lnSpc>
+              <a:spcBef>
+                <a:spcPts val="0"/>
+              </a:spcBef>
+              <a:spcAft>
+                <a:spcPts val="600"/>
+              </a:spcAft>
+            </a:pPr>
+            <a:r>
+              <a:rPr sz="1100" b="0" i="0">
+                <a:solidFill>
+                  <a:srgbClr val="B9B0C8"/>
+                </a:solidFill>
+                <a:latin typeface="Segoe UI"/>
+              </a:rPr>
+              <a:t>Built by Mithun R</a:t>
+            </a:r>
+          </a:p>
+        </p:txBody>
+      </p:sp>
+      <p:sp>
+        <p:nvSpPr>
+          <p:cNvPr id="27" name="TextBox 26"/>
+          <p:cNvSpPr txBox="1"/>
+          <p:nvPr/>
+        </p:nvSpPr>
+        <p:spPr>
+          <a:xfrm>
+            <a:off x="9509760" y="6473952"/>
+            <a:ext cx="1856231" cy="320040"/>
+          </a:xfrm>
+          <a:prstGeom prst="rect">
+            <a:avLst/>
+          </a:prstGeom>
+          <a:noFill/>
+        </p:spPr>
+        <p:txBody>
+          <a:bodyPr wrap="square" anchor="t" lIns="0" rIns="0" tIns="0" bIns="0">
+            <a:spAutoFit/>
+          </a:bodyPr>
+          <a:lstStyle/>
+          <a:p>
+            <a:pPr algn="r">
+              <a:lnSpc>
+                <a:spcPct val="100000"/>
+              </a:lnSpc>
+              <a:spcBef>
+                <a:spcPts val="0"/>
+              </a:spcBef>
+              <a:spcAft>
+                <a:spcPts val="600"/>
+              </a:spcAft>
+            </a:pPr>
+            <a:r>
+              <a:rPr sz="1100" b="1" i="0">
+                <a:solidFill>
+                  <a:srgbClr val="FF9F1C"/>
+                </a:solidFill>
+                <a:latin typeface="Segoe UI"/>
+              </a:rPr>
+              <a:t>06 / 10</a:t>
+            </a:r>
           </a:p>
         </p:txBody>
       </p:sp>
@@ -9784,7 +11275,7 @@
             <a:avLst/>
           </a:prstGeom>
           <a:solidFill>
-            <a:srgbClr val="0E0B16"/>
+            <a:srgbClr val="0C0A14"/>
           </a:solidFill>
           <a:ln>
             <a:noFill/>
@@ -9821,7 +11312,7 @@
         </p:nvSpPr>
         <p:spPr>
           <a:xfrm>
-            <a:off x="822960" y="786384"/>
+            <a:off x="822960" y="822960"/>
             <a:ext cx="82296" cy="310896"/>
           </a:xfrm>
           <a:prstGeom prst="rect">
@@ -9865,7 +11356,7 @@
         </p:nvSpPr>
         <p:spPr>
           <a:xfrm>
-            <a:off x="1024128" y="749808"/>
+            <a:off x="1024128" y="786384"/>
             <a:ext cx="8229600" cy="457200"/>
           </a:xfrm>
           <a:prstGeom prst="rect">
@@ -9910,7 +11401,7 @@
         </p:nvSpPr>
         <p:spPr>
           <a:xfrm>
-            <a:off x="822960" y="1234440"/>
+            <a:off x="822960" y="1188720"/>
             <a:ext cx="10515600" cy="914400"/>
           </a:xfrm>
           <a:prstGeom prst="rect">
@@ -9936,7 +11427,7 @@
               </a:spcAft>
             </a:pPr>
             <a:r>
-              <a:rPr sz="3800" b="1" i="0">
+              <a:rPr sz="3600" b="1" i="0">
                 <a:solidFill>
                   <a:srgbClr val="F7F2E7"/>
                 </a:solidFill>
@@ -9955,7 +11446,7 @@
         </p:nvSpPr>
         <p:spPr>
           <a:xfrm>
-            <a:off x="822960" y="2514600"/>
+            <a:off x="822960" y="2377440"/>
             <a:ext cx="5166360" cy="1005840"/>
           </a:xfrm>
           <a:prstGeom prst="roundRect">
@@ -10001,7 +11492,7 @@
         </p:nvSpPr>
         <p:spPr>
           <a:xfrm>
-            <a:off x="1115568" y="2898648"/>
+            <a:off x="1115568" y="2761488"/>
             <a:ext cx="237744" cy="237744"/>
           </a:xfrm>
           <a:prstGeom prst="ellipse">
@@ -10045,7 +11536,7 @@
         </p:nvSpPr>
         <p:spPr>
           <a:xfrm>
-            <a:off x="1600200" y="2679192"/>
+            <a:off x="1600200" y="2542032"/>
             <a:ext cx="4206240" cy="457200"/>
           </a:xfrm>
           <a:prstGeom prst="rect">
@@ -10090,7 +11581,7 @@
         </p:nvSpPr>
         <p:spPr>
           <a:xfrm>
-            <a:off x="1600200" y="3063240"/>
+            <a:off x="1600200" y="2926080"/>
             <a:ext cx="4206240" cy="457200"/>
           </a:xfrm>
           <a:prstGeom prst="rect">
@@ -10135,7 +11626,7 @@
         </p:nvSpPr>
         <p:spPr>
           <a:xfrm>
-            <a:off x="6172200" y="2514600"/>
+            <a:off x="6172200" y="2377440"/>
             <a:ext cx="5166360" cy="1005840"/>
           </a:xfrm>
           <a:prstGeom prst="roundRect">
@@ -10181,7 +11672,7 @@
         </p:nvSpPr>
         <p:spPr>
           <a:xfrm>
-            <a:off x="6464808" y="2898648"/>
+            <a:off x="6464808" y="2761488"/>
             <a:ext cx="237744" cy="237744"/>
           </a:xfrm>
           <a:prstGeom prst="ellipse">
@@ -10225,7 +11716,7 @@
         </p:nvSpPr>
         <p:spPr>
           <a:xfrm>
-            <a:off x="6949440" y="2679192"/>
+            <a:off x="6949440" y="2542032"/>
             <a:ext cx="4206240" cy="457200"/>
           </a:xfrm>
           <a:prstGeom prst="rect">
@@ -10270,7 +11761,7 @@
         </p:nvSpPr>
         <p:spPr>
           <a:xfrm>
-            <a:off x="6949440" y="3063240"/>
+            <a:off x="6949440" y="2926080"/>
             <a:ext cx="4206240" cy="457200"/>
           </a:xfrm>
           <a:prstGeom prst="rect">
@@ -10315,7 +11806,7 @@
         </p:nvSpPr>
         <p:spPr>
           <a:xfrm>
-            <a:off x="822960" y="3703320"/>
+            <a:off x="822960" y="3566160"/>
             <a:ext cx="5166360" cy="1005840"/>
           </a:xfrm>
           <a:prstGeom prst="roundRect">
@@ -10361,7 +11852,7 @@
         </p:nvSpPr>
         <p:spPr>
           <a:xfrm>
-            <a:off x="1115568" y="4087368"/>
+            <a:off x="1115568" y="3950208"/>
             <a:ext cx="237744" cy="237744"/>
           </a:xfrm>
           <a:prstGeom prst="ellipse">
@@ -10405,7 +11896,7 @@
         </p:nvSpPr>
         <p:spPr>
           <a:xfrm>
-            <a:off x="1600200" y="3867911"/>
+            <a:off x="1600200" y="3730752"/>
             <a:ext cx="4206240" cy="457200"/>
           </a:xfrm>
           <a:prstGeom prst="rect">
@@ -10450,7 +11941,7 @@
         </p:nvSpPr>
         <p:spPr>
           <a:xfrm>
-            <a:off x="1600200" y="4251959"/>
+            <a:off x="1600200" y="4114800"/>
             <a:ext cx="4206240" cy="457200"/>
           </a:xfrm>
           <a:prstGeom prst="rect">
@@ -10495,7 +11986,7 @@
         </p:nvSpPr>
         <p:spPr>
           <a:xfrm>
-            <a:off x="6172200" y="3703320"/>
+            <a:off x="6172200" y="3566160"/>
             <a:ext cx="5166360" cy="1005840"/>
           </a:xfrm>
           <a:prstGeom prst="roundRect">
@@ -10541,7 +12032,7 @@
         </p:nvSpPr>
         <p:spPr>
           <a:xfrm>
-            <a:off x="6464808" y="4087368"/>
+            <a:off x="6464808" y="3950208"/>
             <a:ext cx="237744" cy="237744"/>
           </a:xfrm>
           <a:prstGeom prst="ellipse">
@@ -10585,7 +12076,7 @@
         </p:nvSpPr>
         <p:spPr>
           <a:xfrm>
-            <a:off x="6949440" y="3867911"/>
+            <a:off x="6949440" y="3730752"/>
             <a:ext cx="4206240" cy="457200"/>
           </a:xfrm>
           <a:prstGeom prst="rect">
@@ -10630,7 +12121,7 @@
         </p:nvSpPr>
         <p:spPr>
           <a:xfrm>
-            <a:off x="6949440" y="4251959"/>
+            <a:off x="6949440" y="4114800"/>
             <a:ext cx="4206240" cy="457200"/>
           </a:xfrm>
           <a:prstGeom prst="rect">
@@ -10675,7 +12166,7 @@
         </p:nvSpPr>
         <p:spPr>
           <a:xfrm>
-            <a:off x="822960" y="4892040"/>
+            <a:off x="822960" y="4754880"/>
             <a:ext cx="5166360" cy="1005840"/>
           </a:xfrm>
           <a:prstGeom prst="roundRect">
@@ -10721,7 +12212,7 @@
         </p:nvSpPr>
         <p:spPr>
           <a:xfrm>
-            <a:off x="1115568" y="5276088"/>
+            <a:off x="1115568" y="5138928"/>
             <a:ext cx="237744" cy="237744"/>
           </a:xfrm>
           <a:prstGeom prst="ellipse">
@@ -10765,7 +12256,7 @@
         </p:nvSpPr>
         <p:spPr>
           <a:xfrm>
-            <a:off x="1600200" y="5056631"/>
+            <a:off x="1600200" y="4919472"/>
             <a:ext cx="4206240" cy="457200"/>
           </a:xfrm>
           <a:prstGeom prst="rect">
@@ -10810,7 +12301,7 @@
         </p:nvSpPr>
         <p:spPr>
           <a:xfrm>
-            <a:off x="1600200" y="5440679"/>
+            <a:off x="1600200" y="5303520"/>
             <a:ext cx="4206240" cy="457200"/>
           </a:xfrm>
           <a:prstGeom prst="rect">
@@ -10855,7 +12346,7 @@
         </p:nvSpPr>
         <p:spPr>
           <a:xfrm>
-            <a:off x="6172200" y="4892040"/>
+            <a:off x="6172200" y="4754880"/>
             <a:ext cx="5166360" cy="1005840"/>
           </a:xfrm>
           <a:prstGeom prst="roundRect">
@@ -10901,7 +12392,7 @@
         </p:nvSpPr>
         <p:spPr>
           <a:xfrm>
-            <a:off x="6464808" y="5276088"/>
+            <a:off x="6464808" y="5138928"/>
             <a:ext cx="237744" cy="237744"/>
           </a:xfrm>
           <a:prstGeom prst="ellipse">
@@ -10945,7 +12436,7 @@
         </p:nvSpPr>
         <p:spPr>
           <a:xfrm>
-            <a:off x="6949440" y="5056631"/>
+            <a:off x="6949440" y="4919472"/>
             <a:ext cx="4206240" cy="457200"/>
           </a:xfrm>
           <a:prstGeom prst="rect">
@@ -10990,7 +12481,7 @@
         </p:nvSpPr>
         <p:spPr>
           <a:xfrm>
-            <a:off x="6949440" y="5440679"/>
+            <a:off x="6949440" y="5303520"/>
             <a:ext cx="4206240" cy="457200"/>
           </a:xfrm>
           <a:prstGeom prst="rect">
@@ -11023,6 +12514,185 @@
                 <a:latin typeface="Segoe UI"/>
               </a:rPr>
               <a:t>No login — judges use every feature instantly.</a:t>
+            </a:r>
+          </a:p>
+        </p:txBody>
+      </p:sp>
+      <p:sp>
+        <p:nvSpPr>
+          <p:cNvPr id="30" name="Rectangle 29"/>
+          <p:cNvSpPr/>
+          <p:nvPr/>
+        </p:nvSpPr>
+        <p:spPr>
+          <a:xfrm>
+            <a:off x="822960" y="6419088"/>
+            <a:ext cx="10543032" cy="12801"/>
+          </a:xfrm>
+          <a:prstGeom prst="rect">
+            <a:avLst/>
+          </a:prstGeom>
+          <a:solidFill>
+            <a:srgbClr val="1A142C"/>
+          </a:solidFill>
+          <a:ln>
+            <a:noFill/>
+          </a:ln>
+          <a:effectLst/>
+        </p:spPr>
+        <p:style>
+          <a:lnRef idx="1">
+            <a:schemeClr val="accent1"/>
+          </a:lnRef>
+          <a:fillRef idx="3">
+            <a:schemeClr val="accent1"/>
+          </a:fillRef>
+          <a:effectRef idx="2">
+            <a:schemeClr val="accent1"/>
+          </a:effectRef>
+          <a:fontRef idx="minor">
+            <a:schemeClr val="lt1"/>
+          </a:fontRef>
+        </p:style>
+        <p:txBody>
+          <a:bodyPr rtlCol="0" anchor="ctr"/>
+          <a:lstStyle/>
+          <a:p>
+            <a:pPr algn="ctr"/>
+          </a:p>
+        </p:txBody>
+      </p:sp>
+      <p:sp>
+        <p:nvSpPr>
+          <p:cNvPr id="31" name="TextBox 30"/>
+          <p:cNvSpPr txBox="1"/>
+          <p:nvPr/>
+        </p:nvSpPr>
+        <p:spPr>
+          <a:xfrm>
+            <a:off x="822960" y="6473952"/>
+            <a:ext cx="6400800" cy="320040"/>
+          </a:xfrm>
+          <a:prstGeom prst="rect">
+            <a:avLst/>
+          </a:prstGeom>
+          <a:noFill/>
+        </p:spPr>
+        <p:txBody>
+          <a:bodyPr wrap="square" anchor="t" lIns="0" rIns="0" tIns="0" bIns="0">
+            <a:spAutoFit/>
+          </a:bodyPr>
+          <a:lstStyle/>
+          <a:p>
+            <a:pPr algn="l">
+              <a:lnSpc>
+                <a:spcPct val="100000"/>
+              </a:lnSpc>
+              <a:spcBef>
+                <a:spcPts val="0"/>
+              </a:spcBef>
+              <a:spcAft>
+                <a:spcPts val="600"/>
+              </a:spcAft>
+            </a:pPr>
+            <a:r>
+              <a:rPr sz="1100" b="1" i="0">
+                <a:solidFill>
+                  <a:srgbClr val="B9B0C8"/>
+                </a:solidFill>
+                <a:latin typeface="Segoe UI"/>
+              </a:rPr>
+              <a:t>ಅಕ್ಕ  Akkaverse</a:t>
+            </a:r>
+          </a:p>
+        </p:txBody>
+      </p:sp>
+      <p:sp>
+        <p:nvSpPr>
+          <p:cNvPr id="32" name="TextBox 31"/>
+          <p:cNvSpPr txBox="1"/>
+          <p:nvPr/>
+        </p:nvSpPr>
+        <p:spPr>
+          <a:xfrm>
+            <a:off x="5486400" y="6473952"/>
+            <a:ext cx="3657600" cy="320040"/>
+          </a:xfrm>
+          <a:prstGeom prst="rect">
+            <a:avLst/>
+          </a:prstGeom>
+          <a:noFill/>
+        </p:spPr>
+        <p:txBody>
+          <a:bodyPr wrap="square" anchor="t" lIns="0" rIns="0" tIns="0" bIns="0">
+            <a:spAutoFit/>
+          </a:bodyPr>
+          <a:lstStyle/>
+          <a:p>
+            <a:pPr algn="ctr">
+              <a:lnSpc>
+                <a:spcPct val="100000"/>
+              </a:lnSpc>
+              <a:spcBef>
+                <a:spcPts val="0"/>
+              </a:spcBef>
+              <a:spcAft>
+                <a:spcPts val="600"/>
+              </a:spcAft>
+            </a:pPr>
+            <a:r>
+              <a:rPr sz="1100" b="0" i="0">
+                <a:solidFill>
+                  <a:srgbClr val="B9B0C8"/>
+                </a:solidFill>
+                <a:latin typeface="Segoe UI"/>
+              </a:rPr>
+              <a:t>Built by Mithun R</a:t>
+            </a:r>
+          </a:p>
+        </p:txBody>
+      </p:sp>
+      <p:sp>
+        <p:nvSpPr>
+          <p:cNvPr id="33" name="TextBox 32"/>
+          <p:cNvSpPr txBox="1"/>
+          <p:nvPr/>
+        </p:nvSpPr>
+        <p:spPr>
+          <a:xfrm>
+            <a:off x="9509760" y="6473952"/>
+            <a:ext cx="1856231" cy="320040"/>
+          </a:xfrm>
+          <a:prstGeom prst="rect">
+            <a:avLst/>
+          </a:prstGeom>
+          <a:noFill/>
+        </p:spPr>
+        <p:txBody>
+          <a:bodyPr wrap="square" anchor="t" lIns="0" rIns="0" tIns="0" bIns="0">
+            <a:spAutoFit/>
+          </a:bodyPr>
+          <a:lstStyle/>
+          <a:p>
+            <a:pPr algn="r">
+              <a:lnSpc>
+                <a:spcPct val="100000"/>
+              </a:lnSpc>
+              <a:spcBef>
+                <a:spcPts val="0"/>
+              </a:spcBef>
+              <a:spcAft>
+                <a:spcPts val="600"/>
+              </a:spcAft>
+            </a:pPr>
+            <a:r>
+              <a:rPr sz="1100" b="1" i="0">
+                <a:solidFill>
+                  <a:srgbClr val="FF9F1C"/>
+                </a:solidFill>
+                <a:latin typeface="Segoe UI"/>
+              </a:rPr>
+              <a:t>07 / 10</a:t>
             </a:r>
           </a:p>
         </p:txBody>
@@ -11060,7 +12730,7 @@
             <a:avLst/>
           </a:prstGeom>
           <a:solidFill>
-            <a:srgbClr val="0E0B16"/>
+            <a:srgbClr val="0C0A14"/>
           </a:solidFill>
           <a:ln>
             <a:noFill/>
@@ -11097,7 +12767,7 @@
         </p:nvSpPr>
         <p:spPr>
           <a:xfrm>
-            <a:off x="822960" y="786384"/>
+            <a:off x="822960" y="822960"/>
             <a:ext cx="82296" cy="310896"/>
           </a:xfrm>
           <a:prstGeom prst="rect">
@@ -11141,7 +12811,7 @@
         </p:nvSpPr>
         <p:spPr>
           <a:xfrm>
-            <a:off x="1024128" y="749808"/>
+            <a:off x="1024128" y="786384"/>
             <a:ext cx="8229600" cy="457200"/>
           </a:xfrm>
           <a:prstGeom prst="rect">
@@ -11186,7 +12856,7 @@
         </p:nvSpPr>
         <p:spPr>
           <a:xfrm>
-            <a:off x="822960" y="1234440"/>
+            <a:off x="822960" y="1188720"/>
             <a:ext cx="10515600" cy="914400"/>
           </a:xfrm>
           <a:prstGeom prst="rect">
@@ -11212,7 +12882,7 @@
               </a:spcAft>
             </a:pPr>
             <a:r>
-              <a:rPr sz="3800" b="1" i="0">
+              <a:rPr sz="3600" b="1" i="0">
                 <a:solidFill>
                   <a:srgbClr val="F7F2E7"/>
                 </a:solidFill>
@@ -11231,7 +12901,7 @@
         </p:nvSpPr>
         <p:spPr>
           <a:xfrm>
-            <a:off x="822960" y="2468880"/>
+            <a:off x="822960" y="2331720"/>
             <a:ext cx="10515600" cy="960120"/>
           </a:xfrm>
           <a:prstGeom prst="roundRect">
@@ -11277,7 +12947,7 @@
         </p:nvSpPr>
         <p:spPr>
           <a:xfrm>
-            <a:off x="1097280" y="2487168"/>
+            <a:off x="1097280" y="2350008"/>
             <a:ext cx="10058400" cy="960120"/>
           </a:xfrm>
           <a:prstGeom prst="rect">
@@ -11322,7 +12992,7 @@
         </p:nvSpPr>
         <p:spPr>
           <a:xfrm>
-            <a:off x="822960" y="3657600"/>
+            <a:off x="822960" y="3520440"/>
             <a:ext cx="3383280" cy="2468880"/>
           </a:xfrm>
           <a:prstGeom prst="roundRect">
@@ -11368,7 +13038,7 @@
         </p:nvSpPr>
         <p:spPr>
           <a:xfrm>
-            <a:off x="822960" y="3657600"/>
+            <a:off x="822960" y="3520440"/>
             <a:ext cx="3383280" cy="128016"/>
           </a:xfrm>
           <a:prstGeom prst="rect">
@@ -11412,7 +13082,7 @@
         </p:nvSpPr>
         <p:spPr>
           <a:xfrm>
-            <a:off x="1115568" y="3950208"/>
+            <a:off x="1115568" y="3813048"/>
             <a:ext cx="2834640" cy="548640"/>
           </a:xfrm>
           <a:prstGeom prst="rect">
@@ -11457,7 +13127,7 @@
         </p:nvSpPr>
         <p:spPr>
           <a:xfrm>
-            <a:off x="1115568" y="4617720"/>
+            <a:off x="1115568" y="4480560"/>
             <a:ext cx="2834640" cy="1371600"/>
           </a:xfrm>
           <a:prstGeom prst="rect">
@@ -11502,7 +13172,7 @@
         </p:nvSpPr>
         <p:spPr>
           <a:xfrm>
-            <a:off x="4434840" y="3657600"/>
+            <a:off x="4434840" y="3520440"/>
             <a:ext cx="3383280" cy="2468880"/>
           </a:xfrm>
           <a:prstGeom prst="roundRect">
@@ -11548,7 +13218,7 @@
         </p:nvSpPr>
         <p:spPr>
           <a:xfrm>
-            <a:off x="4434840" y="3657600"/>
+            <a:off x="4434840" y="3520440"/>
             <a:ext cx="3383280" cy="128016"/>
           </a:xfrm>
           <a:prstGeom prst="rect">
@@ -11592,7 +13262,7 @@
         </p:nvSpPr>
         <p:spPr>
           <a:xfrm>
-            <a:off x="4727448" y="3950208"/>
+            <a:off x="4727448" y="3813048"/>
             <a:ext cx="2834640" cy="548640"/>
           </a:xfrm>
           <a:prstGeom prst="rect">
@@ -11637,7 +13307,7 @@
         </p:nvSpPr>
         <p:spPr>
           <a:xfrm>
-            <a:off x="4727448" y="4617720"/>
+            <a:off x="4727448" y="4480560"/>
             <a:ext cx="2834640" cy="1371600"/>
           </a:xfrm>
           <a:prstGeom prst="rect">
@@ -11682,7 +13352,7 @@
         </p:nvSpPr>
         <p:spPr>
           <a:xfrm>
-            <a:off x="8046720" y="3657600"/>
+            <a:off x="8046720" y="3520440"/>
             <a:ext cx="3383280" cy="2468880"/>
           </a:xfrm>
           <a:prstGeom prst="roundRect">
@@ -11728,7 +13398,7 @@
         </p:nvSpPr>
         <p:spPr>
           <a:xfrm>
-            <a:off x="8046720" y="3657600"/>
+            <a:off x="8046720" y="3520440"/>
             <a:ext cx="3383280" cy="128016"/>
           </a:xfrm>
           <a:prstGeom prst="rect">
@@ -11772,7 +13442,7 @@
         </p:nvSpPr>
         <p:spPr>
           <a:xfrm>
-            <a:off x="8339328" y="3950208"/>
+            <a:off x="8339328" y="3813048"/>
             <a:ext cx="2834640" cy="548640"/>
           </a:xfrm>
           <a:prstGeom prst="rect">
@@ -11817,7 +13487,7 @@
         </p:nvSpPr>
         <p:spPr>
           <a:xfrm>
-            <a:off x="8339328" y="4617720"/>
+            <a:off x="8339328" y="4480560"/>
             <a:ext cx="2834640" cy="1371600"/>
           </a:xfrm>
           <a:prstGeom prst="rect">
@@ -11850,6 +13520,185 @@
                 <a:latin typeface="Segoe UI"/>
               </a:rPr>
               <a:t>School / institution licences and an optional opt-in cloud-sync tier for families across devices.</a:t>
+            </a:r>
+          </a:p>
+        </p:txBody>
+      </p:sp>
+      <p:sp>
+        <p:nvSpPr>
+          <p:cNvPr id="20" name="Rectangle 19"/>
+          <p:cNvSpPr/>
+          <p:nvPr/>
+        </p:nvSpPr>
+        <p:spPr>
+          <a:xfrm>
+            <a:off x="822960" y="6419088"/>
+            <a:ext cx="10543032" cy="12801"/>
+          </a:xfrm>
+          <a:prstGeom prst="rect">
+            <a:avLst/>
+          </a:prstGeom>
+          <a:solidFill>
+            <a:srgbClr val="1A142C"/>
+          </a:solidFill>
+          <a:ln>
+            <a:noFill/>
+          </a:ln>
+          <a:effectLst/>
+        </p:spPr>
+        <p:style>
+          <a:lnRef idx="1">
+            <a:schemeClr val="accent1"/>
+          </a:lnRef>
+          <a:fillRef idx="3">
+            <a:schemeClr val="accent1"/>
+          </a:fillRef>
+          <a:effectRef idx="2">
+            <a:schemeClr val="accent1"/>
+          </a:effectRef>
+          <a:fontRef idx="minor">
+            <a:schemeClr val="lt1"/>
+          </a:fontRef>
+        </p:style>
+        <p:txBody>
+          <a:bodyPr rtlCol="0" anchor="ctr"/>
+          <a:lstStyle/>
+          <a:p>
+            <a:pPr algn="ctr"/>
+          </a:p>
+        </p:txBody>
+      </p:sp>
+      <p:sp>
+        <p:nvSpPr>
+          <p:cNvPr id="21" name="TextBox 20"/>
+          <p:cNvSpPr txBox="1"/>
+          <p:nvPr/>
+        </p:nvSpPr>
+        <p:spPr>
+          <a:xfrm>
+            <a:off x="822960" y="6473952"/>
+            <a:ext cx="6400800" cy="320040"/>
+          </a:xfrm>
+          <a:prstGeom prst="rect">
+            <a:avLst/>
+          </a:prstGeom>
+          <a:noFill/>
+        </p:spPr>
+        <p:txBody>
+          <a:bodyPr wrap="square" anchor="t" lIns="0" rIns="0" tIns="0" bIns="0">
+            <a:spAutoFit/>
+          </a:bodyPr>
+          <a:lstStyle/>
+          <a:p>
+            <a:pPr algn="l">
+              <a:lnSpc>
+                <a:spcPct val="100000"/>
+              </a:lnSpc>
+              <a:spcBef>
+                <a:spcPts val="0"/>
+              </a:spcBef>
+              <a:spcAft>
+                <a:spcPts val="600"/>
+              </a:spcAft>
+            </a:pPr>
+            <a:r>
+              <a:rPr sz="1100" b="1" i="0">
+                <a:solidFill>
+                  <a:srgbClr val="B9B0C8"/>
+                </a:solidFill>
+                <a:latin typeface="Segoe UI"/>
+              </a:rPr>
+              <a:t>ಅಕ್ಕ  Akkaverse</a:t>
+            </a:r>
+          </a:p>
+        </p:txBody>
+      </p:sp>
+      <p:sp>
+        <p:nvSpPr>
+          <p:cNvPr id="22" name="TextBox 21"/>
+          <p:cNvSpPr txBox="1"/>
+          <p:nvPr/>
+        </p:nvSpPr>
+        <p:spPr>
+          <a:xfrm>
+            <a:off x="5486400" y="6473952"/>
+            <a:ext cx="3657600" cy="320040"/>
+          </a:xfrm>
+          <a:prstGeom prst="rect">
+            <a:avLst/>
+          </a:prstGeom>
+          <a:noFill/>
+        </p:spPr>
+        <p:txBody>
+          <a:bodyPr wrap="square" anchor="t" lIns="0" rIns="0" tIns="0" bIns="0">
+            <a:spAutoFit/>
+          </a:bodyPr>
+          <a:lstStyle/>
+          <a:p>
+            <a:pPr algn="ctr">
+              <a:lnSpc>
+                <a:spcPct val="100000"/>
+              </a:lnSpc>
+              <a:spcBef>
+                <a:spcPts val="0"/>
+              </a:spcBef>
+              <a:spcAft>
+                <a:spcPts val="600"/>
+              </a:spcAft>
+            </a:pPr>
+            <a:r>
+              <a:rPr sz="1100" b="0" i="0">
+                <a:solidFill>
+                  <a:srgbClr val="B9B0C8"/>
+                </a:solidFill>
+                <a:latin typeface="Segoe UI"/>
+              </a:rPr>
+              <a:t>Built by Mithun R</a:t>
+            </a:r>
+          </a:p>
+        </p:txBody>
+      </p:sp>
+      <p:sp>
+        <p:nvSpPr>
+          <p:cNvPr id="23" name="TextBox 22"/>
+          <p:cNvSpPr txBox="1"/>
+          <p:nvPr/>
+        </p:nvSpPr>
+        <p:spPr>
+          <a:xfrm>
+            <a:off x="9509760" y="6473952"/>
+            <a:ext cx="1856231" cy="320040"/>
+          </a:xfrm>
+          <a:prstGeom prst="rect">
+            <a:avLst/>
+          </a:prstGeom>
+          <a:noFill/>
+        </p:spPr>
+        <p:txBody>
+          <a:bodyPr wrap="square" anchor="t" lIns="0" rIns="0" tIns="0" bIns="0">
+            <a:spAutoFit/>
+          </a:bodyPr>
+          <a:lstStyle/>
+          <a:p>
+            <a:pPr algn="r">
+              <a:lnSpc>
+                <a:spcPct val="100000"/>
+              </a:lnSpc>
+              <a:spcBef>
+                <a:spcPts val="0"/>
+              </a:spcBef>
+              <a:spcAft>
+                <a:spcPts val="600"/>
+              </a:spcAft>
+            </a:pPr>
+            <a:r>
+              <a:rPr sz="1100" b="1" i="0">
+                <a:solidFill>
+                  <a:srgbClr val="FF9F1C"/>
+                </a:solidFill>
+                <a:latin typeface="Segoe UI"/>
+              </a:rPr>
+              <a:t>08 / 10</a:t>
             </a:r>
           </a:p>
         </p:txBody>
@@ -11887,7 +13736,7 @@
             <a:avLst/>
           </a:prstGeom>
           <a:solidFill>
-            <a:srgbClr val="0E0B16"/>
+            <a:srgbClr val="0C0A14"/>
           </a:solidFill>
           <a:ln>
             <a:noFill/>
@@ -11924,7 +13773,7 @@
         </p:nvSpPr>
         <p:spPr>
           <a:xfrm>
-            <a:off x="822960" y="786384"/>
+            <a:off x="822960" y="822960"/>
             <a:ext cx="82296" cy="310896"/>
           </a:xfrm>
           <a:prstGeom prst="rect">
@@ -11968,7 +13817,7 @@
         </p:nvSpPr>
         <p:spPr>
           <a:xfrm>
-            <a:off x="1024128" y="749808"/>
+            <a:off x="1024128" y="786384"/>
             <a:ext cx="8229600" cy="457200"/>
           </a:xfrm>
           <a:prstGeom prst="rect">
@@ -12013,7 +13862,7 @@
         </p:nvSpPr>
         <p:spPr>
           <a:xfrm>
-            <a:off x="822960" y="1234440"/>
+            <a:off x="822960" y="1188720"/>
             <a:ext cx="10515600" cy="914400"/>
           </a:xfrm>
           <a:prstGeom prst="rect">
@@ -12039,7 +13888,7 @@
               </a:spcAft>
             </a:pPr>
             <a:r>
-              <a:rPr sz="3800" b="1" i="0">
+              <a:rPr sz="3600" b="1" i="0">
                 <a:solidFill>
                   <a:srgbClr val="F7F2E7"/>
                 </a:solidFill>
@@ -12058,7 +13907,7 @@
         </p:nvSpPr>
         <p:spPr>
           <a:xfrm>
-            <a:off x="822960" y="2514600"/>
+            <a:off x="822960" y="2377440"/>
             <a:ext cx="3383280" cy="1737360"/>
           </a:xfrm>
           <a:prstGeom prst="roundRect">
@@ -12104,7 +13953,7 @@
         </p:nvSpPr>
         <p:spPr>
           <a:xfrm>
-            <a:off x="1097280" y="2697480"/>
+            <a:off x="1097280" y="2560320"/>
             <a:ext cx="2834640" cy="822960"/>
           </a:xfrm>
           <a:prstGeom prst="rect">
@@ -12149,7 +13998,7 @@
         </p:nvSpPr>
         <p:spPr>
           <a:xfrm>
-            <a:off x="1115568" y="3520440"/>
+            <a:off x="1115568" y="3383280"/>
             <a:ext cx="2926080" cy="731520"/>
           </a:xfrm>
           <a:prstGeom prst="rect">
@@ -12195,7 +14044,7 @@
         </p:nvSpPr>
         <p:spPr>
           <a:xfrm>
-            <a:off x="4434840" y="2514600"/>
+            <a:off x="4434840" y="2377440"/>
             <a:ext cx="3383280" cy="1737360"/>
           </a:xfrm>
           <a:prstGeom prst="roundRect">
@@ -12241,7 +14090,7 @@
         </p:nvSpPr>
         <p:spPr>
           <a:xfrm>
-            <a:off x="4709160" y="2697480"/>
+            <a:off x="4709160" y="2560320"/>
             <a:ext cx="2834640" cy="822960"/>
           </a:xfrm>
           <a:prstGeom prst="rect">
@@ -12286,7 +14135,7 @@
         </p:nvSpPr>
         <p:spPr>
           <a:xfrm>
-            <a:off x="4727448" y="3520440"/>
+            <a:off x="4727448" y="3383280"/>
             <a:ext cx="2926080" cy="731520"/>
           </a:xfrm>
           <a:prstGeom prst="rect">
@@ -12332,7 +14181,7 @@
         </p:nvSpPr>
         <p:spPr>
           <a:xfrm>
-            <a:off x="8046720" y="2514600"/>
+            <a:off x="8046720" y="2377440"/>
             <a:ext cx="3383280" cy="1737360"/>
           </a:xfrm>
           <a:prstGeom prst="roundRect">
@@ -12378,7 +14227,7 @@
         </p:nvSpPr>
         <p:spPr>
           <a:xfrm>
-            <a:off x="8321040" y="2697480"/>
+            <a:off x="8321040" y="2560320"/>
             <a:ext cx="2834640" cy="822960"/>
           </a:xfrm>
           <a:prstGeom prst="rect">
@@ -12423,7 +14272,7 @@
         </p:nvSpPr>
         <p:spPr>
           <a:xfrm>
-            <a:off x="8339328" y="3520440"/>
+            <a:off x="8339328" y="3383280"/>
             <a:ext cx="2926080" cy="731520"/>
           </a:xfrm>
           <a:prstGeom prst="rect">
@@ -12469,7 +14318,7 @@
         </p:nvSpPr>
         <p:spPr>
           <a:xfrm>
-            <a:off x="822960" y="4526280"/>
+            <a:off x="822960" y="4389120"/>
             <a:ext cx="10515600" cy="1600200"/>
           </a:xfrm>
           <a:prstGeom prst="roundRect">
@@ -12515,7 +14364,7 @@
         </p:nvSpPr>
         <p:spPr>
           <a:xfrm>
-            <a:off x="1143000" y="4709160"/>
+            <a:off x="1143000" y="4572000"/>
             <a:ext cx="10058400" cy="1280160"/>
           </a:xfrm>
           <a:prstGeom prst="rect">
@@ -12570,6 +14419,185 @@
                 <a:latin typeface="Segoe UI"/>
               </a:rPr>
               <a:t>Add tester quotes / feedback gathered during the build phase here.</a:t>
+            </a:r>
+          </a:p>
+        </p:txBody>
+      </p:sp>
+      <p:sp>
+        <p:nvSpPr>
+          <p:cNvPr id="17" name="Rectangle 16"/>
+          <p:cNvSpPr/>
+          <p:nvPr/>
+        </p:nvSpPr>
+        <p:spPr>
+          <a:xfrm>
+            <a:off x="822960" y="6419088"/>
+            <a:ext cx="10543032" cy="12801"/>
+          </a:xfrm>
+          <a:prstGeom prst="rect">
+            <a:avLst/>
+          </a:prstGeom>
+          <a:solidFill>
+            <a:srgbClr val="1A142C"/>
+          </a:solidFill>
+          <a:ln>
+            <a:noFill/>
+          </a:ln>
+          <a:effectLst/>
+        </p:spPr>
+        <p:style>
+          <a:lnRef idx="1">
+            <a:schemeClr val="accent1"/>
+          </a:lnRef>
+          <a:fillRef idx="3">
+            <a:schemeClr val="accent1"/>
+          </a:fillRef>
+          <a:effectRef idx="2">
+            <a:schemeClr val="accent1"/>
+          </a:effectRef>
+          <a:fontRef idx="minor">
+            <a:schemeClr val="lt1"/>
+          </a:fontRef>
+        </p:style>
+        <p:txBody>
+          <a:bodyPr rtlCol="0" anchor="ctr"/>
+          <a:lstStyle/>
+          <a:p>
+            <a:pPr algn="ctr"/>
+          </a:p>
+        </p:txBody>
+      </p:sp>
+      <p:sp>
+        <p:nvSpPr>
+          <p:cNvPr id="18" name="TextBox 17"/>
+          <p:cNvSpPr txBox="1"/>
+          <p:nvPr/>
+        </p:nvSpPr>
+        <p:spPr>
+          <a:xfrm>
+            <a:off x="822960" y="6473952"/>
+            <a:ext cx="6400800" cy="320040"/>
+          </a:xfrm>
+          <a:prstGeom prst="rect">
+            <a:avLst/>
+          </a:prstGeom>
+          <a:noFill/>
+        </p:spPr>
+        <p:txBody>
+          <a:bodyPr wrap="square" anchor="t" lIns="0" rIns="0" tIns="0" bIns="0">
+            <a:spAutoFit/>
+          </a:bodyPr>
+          <a:lstStyle/>
+          <a:p>
+            <a:pPr algn="l">
+              <a:lnSpc>
+                <a:spcPct val="100000"/>
+              </a:lnSpc>
+              <a:spcBef>
+                <a:spcPts val="0"/>
+              </a:spcBef>
+              <a:spcAft>
+                <a:spcPts val="600"/>
+              </a:spcAft>
+            </a:pPr>
+            <a:r>
+              <a:rPr sz="1100" b="1" i="0">
+                <a:solidFill>
+                  <a:srgbClr val="B9B0C8"/>
+                </a:solidFill>
+                <a:latin typeface="Segoe UI"/>
+              </a:rPr>
+              <a:t>ಅಕ್ಕ  Akkaverse</a:t>
+            </a:r>
+          </a:p>
+        </p:txBody>
+      </p:sp>
+      <p:sp>
+        <p:nvSpPr>
+          <p:cNvPr id="19" name="TextBox 18"/>
+          <p:cNvSpPr txBox="1"/>
+          <p:nvPr/>
+        </p:nvSpPr>
+        <p:spPr>
+          <a:xfrm>
+            <a:off x="5486400" y="6473952"/>
+            <a:ext cx="3657600" cy="320040"/>
+          </a:xfrm>
+          <a:prstGeom prst="rect">
+            <a:avLst/>
+          </a:prstGeom>
+          <a:noFill/>
+        </p:spPr>
+        <p:txBody>
+          <a:bodyPr wrap="square" anchor="t" lIns="0" rIns="0" tIns="0" bIns="0">
+            <a:spAutoFit/>
+          </a:bodyPr>
+          <a:lstStyle/>
+          <a:p>
+            <a:pPr algn="ctr">
+              <a:lnSpc>
+                <a:spcPct val="100000"/>
+              </a:lnSpc>
+              <a:spcBef>
+                <a:spcPts val="0"/>
+              </a:spcBef>
+              <a:spcAft>
+                <a:spcPts val="600"/>
+              </a:spcAft>
+            </a:pPr>
+            <a:r>
+              <a:rPr sz="1100" b="0" i="0">
+                <a:solidFill>
+                  <a:srgbClr val="B9B0C8"/>
+                </a:solidFill>
+                <a:latin typeface="Segoe UI"/>
+              </a:rPr>
+              <a:t>Built by Mithun R</a:t>
+            </a:r>
+          </a:p>
+        </p:txBody>
+      </p:sp>
+      <p:sp>
+        <p:nvSpPr>
+          <p:cNvPr id="20" name="TextBox 19"/>
+          <p:cNvSpPr txBox="1"/>
+          <p:nvPr/>
+        </p:nvSpPr>
+        <p:spPr>
+          <a:xfrm>
+            <a:off x="9509760" y="6473952"/>
+            <a:ext cx="1856231" cy="320040"/>
+          </a:xfrm>
+          <a:prstGeom prst="rect">
+            <a:avLst/>
+          </a:prstGeom>
+          <a:noFill/>
+        </p:spPr>
+        <p:txBody>
+          <a:bodyPr wrap="square" anchor="t" lIns="0" rIns="0" tIns="0" bIns="0">
+            <a:spAutoFit/>
+          </a:bodyPr>
+          <a:lstStyle/>
+          <a:p>
+            <a:pPr algn="r">
+              <a:lnSpc>
+                <a:spcPct val="100000"/>
+              </a:lnSpc>
+              <a:spcBef>
+                <a:spcPts val="0"/>
+              </a:spcBef>
+              <a:spcAft>
+                <a:spcPts val="600"/>
+              </a:spcAft>
+            </a:pPr>
+            <a:r>
+              <a:rPr sz="1100" b="1" i="0">
+                <a:solidFill>
+                  <a:srgbClr val="FF9F1C"/>
+                </a:solidFill>
+                <a:latin typeface="Segoe UI"/>
+              </a:rPr>
+              <a:t>09 / 10</a:t>
             </a:r>
           </a:p>
         </p:txBody>

</xml_diff>